<commit_message>
L3 rewritten on Opus 5.5 and kept after a blind A/B: 17 of 20 changed pages won, one lost to an orphaned word that is now fixed. The rewrite had already removed the rule that let the planted error through, 'everybody knows it, mark it safe', and the claim that AI never checks its words
Co-Authored-By: Claude Opus 5.5 <noreply@anthropic.com>
Claude-Session: https://claude.ai/code/session_01VWaJFc84eoA3U4f2VjTKjw
</commit_message>
<xml_diff>
--- a/products/ai-fact-check-lab/dist/Hallucination Hunters - Slides.pptx
+++ b/products/ai-fact-check-lab/dist/Hallucination Hunters - Slides.pptx
@@ -513,7 +513,7 @@
           <a:p>
             <a:r>
               <a:rPr lang="en-US" dirty="0"/>
-              <a:t>Open on this slide while students settle. Worksheet: The Fact Desk, one per student. Fully unplugged — devices only add.</a:t>
+              <a:t>Open on this slide while students settle. One Fact Desk worksheet per student. No devices needed.</a:t>
             </a:r>
             <a:endParaRPr lang="en-US" dirty="0"/>
           </a:p>
@@ -601,7 +601,8 @@
           <a:p>
             <a:r>
               <a:rPr lang="en-US" dirty="0"/>
-              <a:t>Expect the fabricated quote in Draft #3 to be named hardest — many students treat quotation marks as proof. Why is a fabricated quote more dangerous than a wrong date? A date is easy to check; a quote borrows a real person's credibility.</a:t>
+              <a:t>Expect the fake quote in Draft #3 to be named hardest. Lots of students treat quotation marks as proof. If nobody names it: "Did anyone check the Edison quote? Why not?" Then ask why a made-up quote is more dangerous than a wrong date. A date is easy to check; a quote borrows a real person's credibility.
+TRANSITION: "Bottom of page 3: Last Check. Solo, four minutes. Two questions, then hand it in."</a:t>
             </a:r>
             <a:endParaRPr lang="en-US" dirty="0"/>
           </a:p>
@@ -689,7 +690,7 @@
           <a:p>
             <a:r>
               <a:rPr lang="en-US" dirty="0"/>
-              <a:t>Bottom of the worksheet. Collect; the Teacher Guide has the scoring key. Full credit on #1 names the mechanism (predicts likely words, doesn't check them). Full credit on #2 names a specific second source — "Google it" gets the push-back: "Google shows you ten sources. Which one, and why that one?"</a:t>
+              <a:t>Bottom of worksheet page 3. Collect; the Teacher Guide has the scoring key. Full credit on #1 names the mechanism: AI predicts likely words, and it doesn't always check them. Full credit on #2 names a specific second source. "Google it" earns partial credit and the push-back: "Google shows you ten sources. Which one, and why that one?"</a:t>
             </a:r>
             <a:endParaRPr lang="en-US" dirty="0"/>
           </a:p>
@@ -777,7 +778,7 @@
           <a:p>
             <a:r>
               <a:rPr lang="en-US" dirty="0"/>
-              <a:t>Close on this. Next in the unit: Teach AI Your Taste (Lesson 4 — in the unit bundle, or sold separately) — using AI as an editor on your own writing without letting it take over.</a:t>
+              <a:t>Close on this. Next in the unit: Teach AI Your Taste (Lesson 4, sold separately). Students use AI as an editor on their own writing without letting it take over.</a:t>
             </a:r>
             <a:endParaRPr lang="en-US" dirty="0"/>
           </a:p>
@@ -865,7 +866,9 @@
           <a:p>
             <a:r>
               <a:rPr lang="en-US" dirty="0"/>
-              <a:t>Read this aloud, smooth and confident, like a news anchor: "Our solar system has eight planets orbiting one star, the Sun. The closest planet to the Sun is Venus, which is also the hottest. Mars is called the Red Planet because rusty iron dust covers its surface. Saturn is famous for its rings — it is the only planet in our solar system that has them. Sunlight takes about eight minutes to reach Earth." Then ask for the vote: "This is going in tomorrow's paper. Print it?" Most classes vote print. Do NOT reveal yet — advance to the question slide. If the room votes HOLD, ask which sentence they doubt — most name Saturn and miss Venus. If a kid names Venus instantly: "Hold that — write it down. We vote first, then we check."</a:t>
+              <a:t>Read this aloud, smooth and confident, like a news anchor: "Our solar system has eight planets orbiting one star, the Sun. The closest planet to the Sun is Venus, which is also the hottest. Mars is called the Red Planet because rusty iron dust covers its surface. Saturn is famous for its rings — it is the only planet in our solar system that has them. Sunlight takes about eight minutes to reach Earth." Then call the vote: "This is going in tomorrow's paper. Print it?" Most classes vote print. Don't reveal yet. Advance to the question slide.
+IF THE ROOM VOTES HOLD: ask which sentence they doubt. Most name Saturn and miss Venus. "One doubt is a start. The desk finds BOTH."
+IF A KID NAMES VENUS INSTANTLY: "Write it down. We vote first, then we check." The second error usually slips past anyway.</a:t>
             </a:r>
             <a:endParaRPr lang="en-US" dirty="0"/>
           </a:p>
@@ -953,7 +956,8 @@
           <a:p>
             <a:r>
               <a:rPr lang="en-US" dirty="0"/>
-              <a:t>Reveal: Mercury is closest to the Sun (Venus really is the hottest — the half-truth makes it slippery), and Saturn isn't alone: Jupiter, Uranus, and Neptune have faint rings too. Bridge: "That paragraph sounded right because it was SMOOTH, not because it was TRUE. AI talks like that all the time — it predicts likely words, it doesn't check them. Today you're the fact desk: nothing runs until you clear it."</a:t>
+              <a:t>REVEAL: Mercury is closest to the Sun (Venus really is the hottest — the half-truth is what makes it slippery), and Saturn isn't alone: Jupiter, Uranus, and Neptune have faint rings too.
+BRIDGE: "That sounded right because it was SMOOTH, not because it was TRUE. AI predicts likely words, and it doesn't always check them. So it can sound exactly like that. Today you're the fact desk: nothing gets printed until you clear it."</a:t>
             </a:r>
             <a:endParaRPr lang="en-US" dirty="0"/>
           </a:p>
@@ -1041,7 +1045,11 @@
           <a:p>
             <a:r>
               <a:rPr lang="en-US" dirty="0"/>
-              <a:t>Why it happens (3 min). Say the quote, then the sub. If your class did the genie lesson: same trickster, new disguise. If someone asks "so is AI always wrong?": "No — it's right a lot. That's what makes it dangerous: you can't tell by the tone. So we check."</a:t>
+              <a:t>Why it happens (3 min). CLASS AUTOCOMPLETE FIRST (1 min): "Finish my sentence. Twinkle, twinkle, little…" (Star.) "Bulls get mad when they see the color…" (Red.) "You just did what AI does: you picked the likely word. The first one was right. The second wasn't. Bulls can't see red well; it's the moving cape."
+THEN: say the quote, then the line under it.
+IF YOUR CLASS DID LESSON 1: "The genie gives you what you SAID. Autocomplete gives you what's LIKELY. Neither one promises what's TRUE."
+IF SOMEONE ASKS "SO IS AI ALWAYS WRONG?": "No, it's right a lot. That's the danger: you can't tell by the tone."
+IF A STUDENT SAYS "MY AI SHOWS LINKS": "Good. Click one. A link counts as a second source only if you open it and it says the same thing."</a:t>
             </a:r>
             <a:endParaRPr lang="en-US" dirty="0"/>
           </a:p>
@@ -1129,7 +1137,7 @@
           <a:p>
             <a:r>
               <a:rPr lang="en-US" dirty="0"/>
-              <a:t>Write the four steps on the board as you go. Model steps 1–2 on the warm-up paragraph: underline "eight planets," "Venus," "Mars," "Saturn," "eight minutes" — then rank. Which claims would embarrass the paper most if wrong? Those get CHECK.</a:t>
+              <a:t>The method (7 min). Walk the four steps. On RANK: "You can't check everything. Would it hurt if wrong? That's a C. Low risk means not a record, not a number, and the ending doesn't need it. That's an S. 'Everybody knows it' is not a reason." Then advance: you model steps 1 and 2 on the next slide.</a:t>
             </a:r>
             <a:endParaRPr lang="en-US" dirty="0"/>
           </a:p>
@@ -1217,7 +1225,7 @@
           <a:p>
             <a:r>
               <a:rPr lang="en-US" dirty="0"/>
-              <a:t>Students' instinct is to ask the AI again. Name it as the trap before the activity. With devices: show a new search tab for one CHECK claim from the warm-up.</a:t>
+              <a:t>MODEL STEPS 1 AND 2 OUT LOUD (still inside the 7-minute method block). Underline five claims: eight planets, Mercury closest, Venus hottest, rusty iron dust, eight minutes. Then mark each one, thinking aloud: "Eight planets: a number. C. Mercury closest: a record word. C. Venus hottest: a record. C. Rusty iron dust: not a record, not a number, nothing leans on it. S. Eight minutes: a number. C." Then: "Four C's out of five. That's normal for a science paragraph. Now which one would embarrass the paper most if it were wrong? Check that one first."</a:t>
             </a:r>
             <a:endParaRPr lang="en-US" dirty="0"/>
           </a:p>
@@ -1305,7 +1313,9 @@
           <a:p>
             <a:r>
               <a:rPr lang="en-US" dirty="0"/>
-              <a:t>Say it plainly and move on. This is the line students quote back all year.</a:t>
+              <a:t>Say the title line, then: "Asking the same AI 'are you sure?' is not a check. LEAVE the answer and open a second, independent source. That's lateral reading." Students' instinct is to ask the AI again, so name it as the trap before the activity. This is the line they quote back all year. With devices: open a new search tab for one C claim from the warm-up.
+IF A STUDENT SAYS "I'D JUST GOOGLE IT": "Google shows you ten sources. Which one, and why that one? Name it. That's the log."
+HAND-OUT: "Pair up. Worksheets out. Deja's note is at the top of page 1. Draft #1 together, seven minutes."</a:t>
             </a:r>
             <a:endParaRPr lang="en-US" dirty="0"/>
           </a:p>
@@ -1393,7 +1403,7 @@
           <a:p>
             <a:r>
               <a:rPr lang="en-US" dirty="0"/>
-              <a:t>Deja's note is at the top of the worksheet: no story gets printed until the desk checks it. Draft #2 is Theo's quiz page; Draft #3 is Marcus's invention feature. Play the editor, not the answer key — when a desk asks "is this one true?", answer "that's a checkable claim — where's your second source?" Keep deadline energy: "Presses roll in five!" ANSWER KEY (notes only): #1 — first crewed Moon landing was 1969, not 1959 (pushback to expect: the uncrewed probe Luna 2 reached the Moon in 1959 — credit it, but "astronauts landed" is still false); the Moon reflects sunlight, it makes none of its own; its ending (brightest night-sky object) is true for the wrong reason. Verdict FIX. #2 — Everest is in the Himalayas in Asia, not the Andes; Australia's capital is Canberra, not Sydney; the three-continents ending no longer follows. Verdict FIX. #3 — Alexander Graham Bell patented the telephone in 1876, not Edison; the Edison quote is fabricated for this exercise and has no source. Verdict KILL. No draft earns RUN today — tell the class that's realistic. Call the swap at the 6-minute mark of Round 2: sheets cross the desk, each partner adds one claim the owner missed, then sheets go straight back. Early finishers: the Extension — write a smooth passage with one planted error and trade. Support: Drafts #1–2 only, hint "each draft hides two false facts (plus a shaky ending)."</a:t>
+              <a:t>Show this while sheets go out, then advance to the rounds. Two failure modes to watch for. The trusting desk clears everything ("it sounded right"): send them back to step 1. The paranoid desk kills everything ("it's all suspicious"): that's what RANK is for. Score the evidence, not the stamp.</a:t>
             </a:r>
             <a:endParaRPr lang="en-US" dirty="0"/>
           </a:p>
@@ -1481,7 +1491,16 @@
           <a:p>
             <a:r>
               <a:rPr lang="en-US" dirty="0"/>
-              <a:t>Leave this up during both rounds. Watch for the two failure modes: the trusting desk clears everything ("it sounded right") — send them back to step 1; the paranoid desk kills everything ("it's all sus") — that's what RANK is for. Score the evidence, not the stamp.</a:t>
+              <a:t>SCRIPT: Deja's note is at the top of the worksheet: no story gets printed until the desk checks it. Play the editor, not the answer key. When a desk asks "is this one true?": "That's a checkable claim. Where's your second source?" Keep deadline energy: "Presses roll in five!"
+ROUND CHANGE (at 7:00): "Round change. Partner A is the partner whose first name comes first in the alphabet. A, take Theo's draft on page 2. B, take Marcus's on page 3. Six minutes, your own sheet. Stamp and note before the swap."
+SWAP (at 6:00 of Round 2): "Swap sheets. Read your partner's log, add one claim they missed in an empty row, and hand it back." At 8:00: "Take your sheet back. If the new claim changes your stamp or note, fix it." A desk of three: each person passes their sheet to the left, then sheets come straight back.
+VERDICTS: "Pens down. Hands up for your stamps first, then I call on desks for evidence." Draft by draft, hands up for RUN, FIX, and KILL; tally one row per draft on the board. Then, for each stamp that got hands, one desk gives its stamp and best evidence: five or six desks in all.
+KEY #1 (Priya): the first crewed Moon landing was 1969, not 1959. Expect pushback: the uncrewed probe Luna 2 reached the Moon in 1959. Credit it, but "astronauts landed" is still false. The Moon reflects sunlight; it makes none of its own. The ending (brightest thing in the night sky) is true for the wrong reason. FIX.
+KEY #2 (Theo): Everest is in the Himalayas in Asia, not the Andes. Australia's capital is Canberra, not Sydney. The three-continent ending no longer follows. FIX.
+KEY #3 (Marcus): Alexander Graham Bell patented the telephone in 1876, not Edison. The Edison quote was written for this exercise and has no source. KILL.
+NO RUN TODAY: "No RUN today, and that's the point. These came straight from an AI helper, and nobody had checked them yet."
+EARLY FINISHERS: the Extension. Write a smooth four-sentence passage with ONE planted error, or none at all. Trade. Your partner has to decide: RUN, FIX, or KILL.
+SUPPORT: Drafts #1–2 only. In Round 2, both partners take Draft #2 and swap as normal. Hint: "Each draft hides two false facts, plus a shaky ending."</a:t>
             </a:r>
             <a:endParaRPr lang="en-US" dirty="0"/>
           </a:p>
@@ -2067,7 +2086,7 @@
                 <a:ea typeface="Arial" pitchFamily="34" charset="-122"/>
                 <a:cs typeface="Arial" pitchFamily="34" charset="-120"/>
               </a:rPr>
-              <a:t>AI predicts likely words, not checked ones — so it can be completely wrong in a totally confident voice. Today you're the fact desk: nothing runs until you clear it.</a:t>
+              <a:t>AI predicts likely words, and it doesn't always check them. It can be completely wrong and sound totally sure. Today you're the fact desk: nothing gets printed until you clear it.</a:t>
             </a:r>
             <a:endParaRPr lang="en-US" sz="1400" dirty="0"/>
           </a:p>
@@ -2325,7 +2344,7 @@
                 <a:ea typeface="Arial" pitchFamily="34" charset="-122"/>
                 <a:cs typeface="Arial" pitchFamily="34" charset="-120"/>
               </a:rPr>
-              <a:t>Which planted error was hardest to catch — and what made it slippery?</a:t>
+              <a:t>Which planted error was hardest to catch, and what made it slippery?</a:t>
             </a:r>
             <a:endParaRPr lang="en-US" sz="1800" dirty="0"/>
           </a:p>
@@ -2346,7 +2365,7 @@
                 <a:ea typeface="Arial" pitchFamily="34" charset="-122"/>
                 <a:cs typeface="Arial" pitchFamily="34" charset="-120"/>
               </a:rPr>
-              <a:t>Where else does confident-but-wrong show up? Feeds, group chats, AI homework helpers...</a:t>
+              <a:t>Where else does confident-but-wrong show up? Feeds, group chats, AI homework helpers…</a:t>
             </a:r>
             <a:endParaRPr lang="en-US" sz="1800" dirty="0"/>
           </a:p>
@@ -2625,7 +2644,7 @@
                 <a:ea typeface="Arial" pitchFamily="34" charset="-122"/>
                 <a:cs typeface="Arial" pitchFamily="34" charset="-120"/>
               </a:rPr>
-              <a:t>1.  In your own words: how can AI sound 100% sure and still be wrong?</a:t>
+              <a:t>In your own words: how can AI sound 100% sure and still be wrong?</a:t>
             </a:r>
             <a:endParaRPr lang="en-US" sz="1800" dirty="0"/>
           </a:p>
@@ -2646,7 +2665,7 @@
                 <a:ea typeface="Arial" pitchFamily="34" charset="-122"/>
                 <a:cs typeface="Arial" pitchFamily="34" charset="-120"/>
               </a:rPr>
-              <a:t>2.  Name one checkable claim (a name, date, number, place, or quote) you saw online this week — or one you expect to see. Where would you check it? Name a second source that is NOT the place you first saw it (a textbook, an encyclopedia, a different website).</a:t>
+              <a:t>Name one checkable claim (a name, date, number, place, or quote) you saw or heard this week. Name a second source where you would check it. It can't be the place you first saw or heard it.</a:t>
             </a:r>
             <a:endParaRPr lang="en-US" sz="1800" dirty="0"/>
           </a:p>
@@ -2859,7 +2878,7 @@
                 <a:ea typeface="Arial" pitchFamily="34" charset="-122"/>
                 <a:cs typeface="Arial" pitchFamily="34" charset="-120"/>
               </a:rPr>
-              <a:t>Desk rule to keep: before you repeat it, post it, or hand it in — check it. The desk is a habit, not a job.</a:t>
+              <a:t>Desk rule to keep: before you repeat it, post it, or hand it in — check it. You don't need a desk to do this. You need the habit.</a:t>
             </a:r>
             <a:endParaRPr lang="en-US" sz="1600" dirty="0"/>
           </a:p>
@@ -3179,7 +3198,7 @@
                 <a:ea typeface="Arial" pitchFamily="34" charset="-122"/>
                 <a:cs typeface="Arial" pitchFamily="34" charset="-120"/>
               </a:rPr>
-              <a:t>Listen once, like an editor. No notes yet — just your first feeling.</a:t>
+              <a:t>Listen once, like an editor. No notes yet, just your first feeling.</a:t>
             </a:r>
             <a:endParaRPr lang="en-US" sz="1500" dirty="0"/>
           </a:p>
@@ -3577,7 +3596,7 @@
                 <a:ea typeface="Arial" pitchFamily="34" charset="-122"/>
                 <a:cs typeface="Arial" pitchFamily="34" charset="-120"/>
               </a:rPr>
-              <a:t>Smooth is not the same as true. That paragraph was written to sound like an expert.</a:t>
+              <a:t>Name the sentence first. Then say what made you believe it.</a:t>
             </a:r>
             <a:endParaRPr lang="en-US" sz="1600" dirty="0"/>
           </a:p>
@@ -4423,7 +4442,7 @@
                 <a:ea typeface="Arial" pitchFamily="34" charset="-122"/>
                 <a:cs typeface="Arial" pitchFamily="34" charset="-120"/>
               </a:rPr>
-              <a:t>You can't check everything. Would it hurt if wrong? Mark C. Everybody knows it? Mark S.</a:t>
+              <a:t>Would it hurt if wrong? Mark C. Low risk? Mark S. "Everybody knows it" is not a reason.</a:t>
             </a:r>
             <a:endParaRPr lang="en-US" sz="1400" dirty="0"/>
           </a:p>
@@ -4761,7 +4780,7 @@
                 <a:ea typeface="Arial" pitchFamily="34" charset="-122"/>
                 <a:cs typeface="Arial" pitchFamily="34" charset="-120"/>
               </a:rPr>
-              <a:t>RUN (clean) · FIX (correct it, then print) · KILL (the core claim fails — cut the story).</a:t>
+              <a:t>RUN (clean) · FIX (correct it, then print) · KILL (core claim fails, cut the story).</a:t>
             </a:r>
             <a:endParaRPr lang="en-US" sz="1400" dirty="0"/>
           </a:p>
@@ -4910,7 +4929,7 @@
                 <a:ea typeface="Arial" pitchFamily="34" charset="-122"/>
                 <a:cs typeface="Arial" pitchFamily="34" charset="-120"/>
               </a:rPr>
-              <a:t>What counts as a check?</a:t>
+              <a:t>The warm-up, corrected</a:t>
             </a:r>
             <a:endParaRPr lang="en-US" sz="2600" dirty="0"/>
           </a:p>
@@ -4918,41 +4937,14 @@
       </p:sp>
       <p:sp>
         <p:nvSpPr>
-          <p:cNvPr id="6" name="Shape 3"/>
-          <p:cNvSpPr/>
-          <p:nvPr/>
-        </p:nvSpPr>
-        <p:spPr>
-          <a:xfrm>
-            <a:off x="502920" y="1188720"/>
-            <a:ext cx="3931920" cy="3406140"/>
-          </a:xfrm>
-          <a:prstGeom prst="roundRect">
-            <a:avLst>
-              <a:gd name="adj" fmla="val 3758"/>
-            </a:avLst>
-          </a:prstGeom>
-          <a:solidFill>
-            <a:srgbClr val="262648"/>
-          </a:solidFill>
-          <a:ln w="12700">
-            <a:solidFill>
-              <a:srgbClr val="262648"/>
-            </a:solidFill>
-            <a:prstDash val="solid"/>
-          </a:ln>
-        </p:spPr>
-      </p:sp>
-      <p:sp>
-        <p:nvSpPr>
-          <p:cNvPr id="7" name="Text 4"/>
-          <p:cNvSpPr txBox="1"/>
-          <p:nvPr/>
-        </p:nvSpPr>
-        <p:spPr>
-          <a:xfrm>
-            <a:off x="731520" y="1371600"/>
-            <a:ext cx="3474720" cy="365760"/>
+          <p:cNvPr id="6" name="Text 3"/>
+          <p:cNvSpPr txBox="1"/>
+          <p:nvPr/>
+        </p:nvSpPr>
+        <p:spPr>
+          <a:xfrm>
+            <a:off x="594360" y="1188720"/>
+            <a:ext cx="7955280" cy="3406140"/>
           </a:xfrm>
           <a:prstGeom prst="rect">
             <a:avLst/>
@@ -4964,165 +4956,109 @@
           <a:bodyPr wrap="square" lIns="0" tIns="0" rIns="0" bIns="0" rtlCol="0" anchor="t"/>
           <a:lstStyle/>
           <a:p>
-            <a:pPr indent="0" marL="0">
-              <a:buNone/>
-            </a:pPr>
-            <a:r>
-              <a:rPr lang="en-US" sz="1300" b="1" spc="100" kern="0" dirty="0">
-                <a:solidFill>
-                  <a:srgbClr val="A9A9C4"/>
-                </a:solidFill>
-                <a:latin typeface="Arial" pitchFamily="34" charset="0"/>
-                <a:ea typeface="Arial" pitchFamily="34" charset="-122"/>
-                <a:cs typeface="Arial" pitchFamily="34" charset="-120"/>
-              </a:rPr>
-              <a:t>NOT A CHECK</a:t>
-            </a:r>
-            <a:endParaRPr lang="en-US" sz="1300" dirty="0"/>
-          </a:p>
-        </p:txBody>
-      </p:sp>
-      <p:sp>
-        <p:nvSpPr>
-          <p:cNvPr id="8" name="Text 5"/>
-          <p:cNvSpPr txBox="1"/>
-          <p:nvPr/>
-        </p:nvSpPr>
-        <p:spPr>
-          <a:xfrm>
-            <a:off x="731520" y="1828800"/>
-            <a:ext cx="3474720" cy="2583180"/>
-          </a:xfrm>
-          <a:prstGeom prst="rect">
-            <a:avLst/>
-          </a:prstGeom>
-          <a:noFill/>
-          <a:ln/>
-        </p:spPr>
-        <p:txBody>
-          <a:bodyPr wrap="square" lIns="0" tIns="0" rIns="0" bIns="0" rtlCol="0" anchor="t"/>
-          <a:lstStyle/>
-          <a:p>
-            <a:pPr indent="0" marL="0">
-              <a:buNone/>
-            </a:pPr>
-            <a:r>
-              <a:rPr lang="en-US" sz="1700" dirty="0">
-                <a:solidFill>
-                  <a:srgbClr val="FFFFFF"/>
-                </a:solidFill>
-                <a:latin typeface="Arial" pitchFamily="34" charset="0"/>
-                <a:ea typeface="Arial" pitchFamily="34" charset="-122"/>
-                <a:cs typeface="Arial" pitchFamily="34" charset="-120"/>
-              </a:rPr>
-              <a:t>Asking the same AI "Are you sure?" Same source, same guess, same confident voice.</a:t>
-            </a:r>
-            <a:endParaRPr lang="en-US" sz="1700" dirty="0"/>
-          </a:p>
-        </p:txBody>
-      </p:sp>
-      <p:sp>
-        <p:nvSpPr>
-          <p:cNvPr id="9" name="Shape 6"/>
-          <p:cNvSpPr/>
-          <p:nvPr/>
-        </p:nvSpPr>
-        <p:spPr>
-          <a:xfrm>
-            <a:off x="4709160" y="1188720"/>
-            <a:ext cx="3931920" cy="3406140"/>
-          </a:xfrm>
-          <a:prstGeom prst="roundRect">
-            <a:avLst>
-              <a:gd name="adj" fmla="val 3758"/>
-            </a:avLst>
-          </a:prstGeom>
-          <a:solidFill>
-            <a:srgbClr val="2F2A5C"/>
-          </a:solidFill>
-          <a:ln w="19050">
-            <a:solidFill>
-              <a:srgbClr val="FFB020"/>
-            </a:solidFill>
-            <a:prstDash val="solid"/>
-          </a:ln>
-        </p:spPr>
-      </p:sp>
-      <p:sp>
-        <p:nvSpPr>
-          <p:cNvPr id="10" name="Text 7"/>
-          <p:cNvSpPr txBox="1"/>
-          <p:nvPr/>
-        </p:nvSpPr>
-        <p:spPr>
-          <a:xfrm>
-            <a:off x="4937760" y="1371600"/>
-            <a:ext cx="3474720" cy="365760"/>
-          </a:xfrm>
-          <a:prstGeom prst="rect">
-            <a:avLst/>
-          </a:prstGeom>
-          <a:noFill/>
-          <a:ln/>
-        </p:spPr>
-        <p:txBody>
-          <a:bodyPr wrap="square" lIns="0" tIns="0" rIns="0" bIns="0" rtlCol="0" anchor="t"/>
-          <a:lstStyle/>
-          <a:p>
-            <a:pPr indent="0" marL="0">
-              <a:buNone/>
-            </a:pPr>
-            <a:r>
-              <a:rPr lang="en-US" sz="1300" b="1" spc="100" kern="0" dirty="0">
-                <a:solidFill>
-                  <a:srgbClr val="FFB020"/>
-                </a:solidFill>
-                <a:latin typeface="Arial" pitchFamily="34" charset="0"/>
-                <a:ea typeface="Arial" pitchFamily="34" charset="-122"/>
-                <a:cs typeface="Arial" pitchFamily="34" charset="-120"/>
-              </a:rPr>
-              <a:t>LATERAL READING</a:t>
-            </a:r>
-            <a:endParaRPr lang="en-US" sz="1300" dirty="0"/>
-          </a:p>
-        </p:txBody>
-      </p:sp>
-      <p:sp>
-        <p:nvSpPr>
-          <p:cNvPr id="11" name="Text 8"/>
-          <p:cNvSpPr txBox="1"/>
-          <p:nvPr/>
-        </p:nvSpPr>
-        <p:spPr>
-          <a:xfrm>
-            <a:off x="4937760" y="1828800"/>
-            <a:ext cx="3474720" cy="2583180"/>
-          </a:xfrm>
-          <a:prstGeom prst="rect">
-            <a:avLst/>
-          </a:prstGeom>
-          <a:noFill/>
-          <a:ln/>
-        </p:spPr>
-        <p:txBody>
-          <a:bodyPr wrap="square" lIns="0" tIns="0" rIns="0" bIns="0" rtlCol="0" anchor="t"/>
-          <a:lstStyle/>
-          <a:p>
-            <a:pPr indent="0" marL="0">
-              <a:buNone/>
-            </a:pPr>
-            <a:r>
-              <a:rPr lang="en-US" sz="1700" dirty="0">
-                <a:solidFill>
-                  <a:srgbClr val="FFFFFF"/>
-                </a:solidFill>
-                <a:latin typeface="Arial" pitchFamily="34" charset="0"/>
-                <a:ea typeface="Arial" pitchFamily="34" charset="-122"/>
-                <a:cs typeface="Arial" pitchFamily="34" charset="-120"/>
-              </a:rPr>
-              <a:t>Leave the answer. Open a second, independent source — encyclopedia, textbook, a new search tab. Does it agree?</a:t>
-            </a:r>
-            <a:endParaRPr lang="en-US" sz="1700" dirty="0"/>
+            <a:pPr marL="342900" indent="-342900">
+              <a:spcAft>
+                <a:spcPts val="800"/>
+              </a:spcAft>
+              <a:buSzPct val="100000"/>
+              <a:buChar char="■"/>
+            </a:pPr>
+            <a:r>
+              <a:rPr lang="en-US" sz="1800" dirty="0">
+                <a:solidFill>
+                  <a:srgbClr val="E8E8F5"/>
+                </a:solidFill>
+                <a:latin typeface="Arial" pitchFamily="34" charset="0"/>
+                <a:ea typeface="Arial" pitchFamily="34" charset="-122"/>
+                <a:cs typeface="Arial" pitchFamily="34" charset="-120"/>
+              </a:rPr>
+              <a:t>Our solar system has eight planets orbiting one star, the Sun.</a:t>
+            </a:r>
+            <a:endParaRPr lang="en-US" sz="1800" dirty="0"/>
+          </a:p>
+          <a:p>
+            <a:pPr marL="342900" indent="-342900">
+              <a:spcAft>
+                <a:spcPts val="800"/>
+              </a:spcAft>
+              <a:buSzPct val="100000"/>
+              <a:buChar char="■"/>
+            </a:pPr>
+            <a:r>
+              <a:rPr lang="en-US" sz="1800" dirty="0">
+                <a:solidFill>
+                  <a:srgbClr val="E8E8F5"/>
+                </a:solidFill>
+                <a:latin typeface="Arial" pitchFamily="34" charset="0"/>
+                <a:ea typeface="Arial" pitchFamily="34" charset="-122"/>
+                <a:cs typeface="Arial" pitchFamily="34" charset="-120"/>
+              </a:rPr>
+              <a:t>The closest planet to the Sun is Mercury (not Venus). Venus is the hottest.</a:t>
+            </a:r>
+            <a:endParaRPr lang="en-US" sz="1800" dirty="0"/>
+          </a:p>
+          <a:p>
+            <a:pPr marL="342900" indent="-342900">
+              <a:spcAft>
+                <a:spcPts val="800"/>
+              </a:spcAft>
+              <a:buSzPct val="100000"/>
+              <a:buChar char="■"/>
+            </a:pPr>
+            <a:r>
+              <a:rPr lang="en-US" sz="1800" dirty="0">
+                <a:solidFill>
+                  <a:srgbClr val="E8E8F5"/>
+                </a:solidFill>
+                <a:latin typeface="Arial" pitchFamily="34" charset="0"/>
+                <a:ea typeface="Arial" pitchFamily="34" charset="-122"/>
+                <a:cs typeface="Arial" pitchFamily="34" charset="-120"/>
+              </a:rPr>
+              <a:t>Mars is called the Red Planet because rusty iron dust covers its surface.</a:t>
+            </a:r>
+            <a:endParaRPr lang="en-US" sz="1800" dirty="0"/>
+          </a:p>
+          <a:p>
+            <a:pPr marL="342900" indent="-342900">
+              <a:spcAft>
+                <a:spcPts val="800"/>
+              </a:spcAft>
+              <a:buSzPct val="100000"/>
+              <a:buChar char="■"/>
+            </a:pPr>
+            <a:r>
+              <a:rPr lang="en-US" sz="1800" dirty="0">
+                <a:solidFill>
+                  <a:srgbClr val="E8E8F5"/>
+                </a:solidFill>
+                <a:latin typeface="Arial" pitchFamily="34" charset="0"/>
+                <a:ea typeface="Arial" pitchFamily="34" charset="-122"/>
+                <a:cs typeface="Arial" pitchFamily="34" charset="-120"/>
+              </a:rPr>
+              <a:t>Saturn is famous for its rings. Jupiter, Uranus, and Neptune have faint ones.</a:t>
+            </a:r>
+            <a:endParaRPr lang="en-US" sz="1800" dirty="0"/>
+          </a:p>
+          <a:p>
+            <a:pPr marL="342900" indent="-342900">
+              <a:spcAft>
+                <a:spcPts val="800"/>
+              </a:spcAft>
+              <a:buSzPct val="100000"/>
+              <a:buChar char="■"/>
+            </a:pPr>
+            <a:r>
+              <a:rPr lang="en-US" sz="1800" dirty="0">
+                <a:solidFill>
+                  <a:srgbClr val="E8E8F5"/>
+                </a:solidFill>
+                <a:latin typeface="Arial" pitchFamily="34" charset="0"/>
+                <a:ea typeface="Arial" pitchFamily="34" charset="-122"/>
+                <a:cs typeface="Arial" pitchFamily="34" charset="-120"/>
+              </a:rPr>
+              <a:t>Sunlight takes about eight minutes to reach Earth.</a:t>
+            </a:r>
+            <a:endParaRPr lang="en-US" sz="1800" dirty="0"/>
           </a:p>
         </p:txBody>
       </p:sp>
@@ -5238,14 +5174,80 @@
       </p:sp>
       <p:sp>
         <p:nvSpPr>
-          <p:cNvPr id="5" name="Text 2"/>
-          <p:cNvSpPr txBox="1"/>
-          <p:nvPr/>
-        </p:nvSpPr>
-        <p:spPr>
-          <a:xfrm>
-            <a:off x="502920" y="457200"/>
-            <a:ext cx="1005840" cy="2011680"/>
+          <p:cNvPr id="4" name="Text 2"/>
+          <p:cNvSpPr txBox="1"/>
+          <p:nvPr/>
+        </p:nvSpPr>
+        <p:spPr>
+          <a:xfrm>
+            <a:off x="502920" y="502920"/>
+            <a:ext cx="8138160" cy="548640"/>
+          </a:xfrm>
+          <a:prstGeom prst="rect">
+            <a:avLst/>
+          </a:prstGeom>
+          <a:noFill/>
+          <a:ln/>
+        </p:spPr>
+        <p:txBody>
+          <a:bodyPr wrap="square" lIns="0" tIns="0" rIns="0" bIns="0" rtlCol="0" anchor="ctr"/>
+          <a:lstStyle/>
+          <a:p>
+            <a:pPr indent="0" marL="0">
+              <a:buNone/>
+            </a:pPr>
+            <a:r>
+              <a:rPr lang="en-US" sz="2200" b="1" dirty="0">
+                <a:solidFill>
+                  <a:srgbClr val="FFB020"/>
+                </a:solidFill>
+                <a:latin typeface="Arial" pitchFamily="34" charset="0"/>
+                <a:ea typeface="Arial" pitchFamily="34" charset="-122"/>
+                <a:cs typeface="Arial" pitchFamily="34" charset="-120"/>
+              </a:rPr>
+              <a:t>Don't ask the suspect if they're innocent.</a:t>
+            </a:r>
+            <a:endParaRPr lang="en-US" sz="2200" dirty="0"/>
+          </a:p>
+        </p:txBody>
+      </p:sp>
+      <p:sp>
+        <p:nvSpPr>
+          <p:cNvPr id="6" name="Shape 3"/>
+          <p:cNvSpPr/>
+          <p:nvPr/>
+        </p:nvSpPr>
+        <p:spPr>
+          <a:xfrm>
+            <a:off x="502920" y="1188720"/>
+            <a:ext cx="3931920" cy="3406140"/>
+          </a:xfrm>
+          <a:prstGeom prst="roundRect">
+            <a:avLst>
+              <a:gd name="adj" fmla="val 3758"/>
+            </a:avLst>
+          </a:prstGeom>
+          <a:solidFill>
+            <a:srgbClr val="262648"/>
+          </a:solidFill>
+          <a:ln w="12700">
+            <a:solidFill>
+              <a:srgbClr val="262648"/>
+            </a:solidFill>
+            <a:prstDash val="solid"/>
+          </a:ln>
+        </p:spPr>
+      </p:sp>
+      <p:sp>
+        <p:nvSpPr>
+          <p:cNvPr id="7" name="Text 4"/>
+          <p:cNvSpPr txBox="1"/>
+          <p:nvPr/>
+        </p:nvSpPr>
+        <p:spPr>
+          <a:xfrm>
+            <a:off x="731520" y="1371600"/>
+            <a:ext cx="3474720" cy="365760"/>
           </a:xfrm>
           <a:prstGeom prst="rect">
             <a:avLst/>
@@ -5261,7 +5263,112 @@
               <a:buNone/>
             </a:pPr>
             <a:r>
-              <a:rPr lang="en-US" sz="11000" b="1" dirty="0">
+              <a:rPr lang="en-US" sz="1300" b="1" spc="100" kern="0" dirty="0">
+                <a:solidFill>
+                  <a:srgbClr val="A9A9C4"/>
+                </a:solidFill>
+                <a:latin typeface="Arial" pitchFamily="34" charset="0"/>
+                <a:ea typeface="Arial" pitchFamily="34" charset="-122"/>
+                <a:cs typeface="Arial" pitchFamily="34" charset="-120"/>
+              </a:rPr>
+              <a:t>NOT A CHECK</a:t>
+            </a:r>
+            <a:endParaRPr lang="en-US" sz="1300" dirty="0"/>
+          </a:p>
+        </p:txBody>
+      </p:sp>
+      <p:sp>
+        <p:nvSpPr>
+          <p:cNvPr id="8" name="Text 5"/>
+          <p:cNvSpPr txBox="1"/>
+          <p:nvPr/>
+        </p:nvSpPr>
+        <p:spPr>
+          <a:xfrm>
+            <a:off x="731520" y="1828800"/>
+            <a:ext cx="3474720" cy="2583180"/>
+          </a:xfrm>
+          <a:prstGeom prst="rect">
+            <a:avLst/>
+          </a:prstGeom>
+          <a:noFill/>
+          <a:ln/>
+        </p:spPr>
+        <p:txBody>
+          <a:bodyPr wrap="square" lIns="0" tIns="0" rIns="0" bIns="0" rtlCol="0" anchor="t"/>
+          <a:lstStyle/>
+          <a:p>
+            <a:pPr indent="0" marL="0">
+              <a:buNone/>
+            </a:pPr>
+            <a:r>
+              <a:rPr lang="en-US" sz="1700" dirty="0">
+                <a:solidFill>
+                  <a:srgbClr val="FFFFFF"/>
+                </a:solidFill>
+                <a:latin typeface="Arial" pitchFamily="34" charset="0"/>
+                <a:ea typeface="Arial" pitchFamily="34" charset="-122"/>
+                <a:cs typeface="Arial" pitchFamily="34" charset="-120"/>
+              </a:rPr>
+              <a:t>Asking the same AI "Are you sure?" Same source, same guess, same confident voice.</a:t>
+            </a:r>
+            <a:endParaRPr lang="en-US" sz="1700" dirty="0"/>
+          </a:p>
+        </p:txBody>
+      </p:sp>
+      <p:sp>
+        <p:nvSpPr>
+          <p:cNvPr id="9" name="Shape 6"/>
+          <p:cNvSpPr/>
+          <p:nvPr/>
+        </p:nvSpPr>
+        <p:spPr>
+          <a:xfrm>
+            <a:off x="4709160" y="1188720"/>
+            <a:ext cx="3931920" cy="3406140"/>
+          </a:xfrm>
+          <a:prstGeom prst="roundRect">
+            <a:avLst>
+              <a:gd name="adj" fmla="val 3758"/>
+            </a:avLst>
+          </a:prstGeom>
+          <a:solidFill>
+            <a:srgbClr val="2F2A5C"/>
+          </a:solidFill>
+          <a:ln w="19050">
+            <a:solidFill>
+              <a:srgbClr val="FFB020"/>
+            </a:solidFill>
+            <a:prstDash val="solid"/>
+          </a:ln>
+        </p:spPr>
+      </p:sp>
+      <p:sp>
+        <p:nvSpPr>
+          <p:cNvPr id="10" name="Text 7"/>
+          <p:cNvSpPr txBox="1"/>
+          <p:nvPr/>
+        </p:nvSpPr>
+        <p:spPr>
+          <a:xfrm>
+            <a:off x="4937760" y="1371600"/>
+            <a:ext cx="3474720" cy="365760"/>
+          </a:xfrm>
+          <a:prstGeom prst="rect">
+            <a:avLst/>
+          </a:prstGeom>
+          <a:noFill/>
+          <a:ln/>
+        </p:spPr>
+        <p:txBody>
+          <a:bodyPr wrap="square" lIns="0" tIns="0" rIns="0" bIns="0" rtlCol="0" anchor="t"/>
+          <a:lstStyle/>
+          <a:p>
+            <a:pPr indent="0" marL="0">
+              <a:buNone/>
+            </a:pPr>
+            <a:r>
+              <a:rPr lang="en-US" sz="1300" b="1" spc="100" kern="0" dirty="0">
                 <a:solidFill>
                   <a:srgbClr val="FFB020"/>
                 </a:solidFill>
@@ -5269,38 +5376,38 @@
                 <a:ea typeface="Arial" pitchFamily="34" charset="-122"/>
                 <a:cs typeface="Arial" pitchFamily="34" charset="-120"/>
               </a:rPr>
-              <a:t>“</a:t>
-            </a:r>
-            <a:endParaRPr lang="en-US" sz="11000" dirty="0"/>
-          </a:p>
-        </p:txBody>
-      </p:sp>
-      <p:sp>
-        <p:nvSpPr>
-          <p:cNvPr id="6" name="Text 3"/>
-          <p:cNvSpPr txBox="1"/>
-          <p:nvPr/>
-        </p:nvSpPr>
-        <p:spPr>
-          <a:xfrm>
-            <a:off x="1554480" y="685800"/>
-            <a:ext cx="7086600" cy="2267255"/>
-          </a:xfrm>
-          <a:prstGeom prst="rect">
-            <a:avLst/>
-          </a:prstGeom>
-          <a:noFill/>
-          <a:ln/>
-        </p:spPr>
-        <p:txBody>
-          <a:bodyPr wrap="square" lIns="0" tIns="0" rIns="0" bIns="0" rtlCol="0" anchor="ctr"/>
+              <a:t>LATERAL READING</a:t>
+            </a:r>
+            <a:endParaRPr lang="en-US" sz="1300" dirty="0"/>
+          </a:p>
+        </p:txBody>
+      </p:sp>
+      <p:sp>
+        <p:nvSpPr>
+          <p:cNvPr id="11" name="Text 8"/>
+          <p:cNvSpPr txBox="1"/>
+          <p:nvPr/>
+        </p:nvSpPr>
+        <p:spPr>
+          <a:xfrm>
+            <a:off x="4937760" y="1828800"/>
+            <a:ext cx="3474720" cy="2583180"/>
+          </a:xfrm>
+          <a:prstGeom prst="rect">
+            <a:avLst/>
+          </a:prstGeom>
+          <a:noFill/>
+          <a:ln/>
+        </p:spPr>
+        <p:txBody>
+          <a:bodyPr wrap="square" lIns="0" tIns="0" rIns="0" bIns="0" rtlCol="0" anchor="t"/>
           <a:lstStyle/>
           <a:p>
             <a:pPr indent="0" marL="0">
               <a:buNone/>
             </a:pPr>
             <a:r>
-              <a:rPr lang="en-US" sz="2800" i="1" dirty="0">
+              <a:rPr lang="en-US" sz="1700" dirty="0">
                 <a:solidFill>
                   <a:srgbClr val="FFFFFF"/>
                 </a:solidFill>
@@ -5308,48 +5415,9 @@
                 <a:ea typeface="Arial" pitchFamily="34" charset="-122"/>
                 <a:cs typeface="Arial" pitchFamily="34" charset="-120"/>
               </a:rPr>
-              <a:t>Don't ask the suspect if they're innocent.</a:t>
-            </a:r>
-            <a:endParaRPr lang="en-US" sz="2800" dirty="0"/>
-          </a:p>
-        </p:txBody>
-      </p:sp>
-      <p:sp>
-        <p:nvSpPr>
-          <p:cNvPr id="7" name="Text 4"/>
-          <p:cNvSpPr txBox="1"/>
-          <p:nvPr/>
-        </p:nvSpPr>
-        <p:spPr>
-          <a:xfrm>
-            <a:off x="1554480" y="3090215"/>
-            <a:ext cx="7086600" cy="1504645"/>
-          </a:xfrm>
-          <a:prstGeom prst="rect">
-            <a:avLst/>
-          </a:prstGeom>
-          <a:noFill/>
-          <a:ln/>
-        </p:spPr>
-        <p:txBody>
-          <a:bodyPr wrap="square" lIns="0" tIns="0" rIns="0" bIns="0" rtlCol="0" anchor="t"/>
-          <a:lstStyle/>
-          <a:p>
-            <a:pPr indent="0" marL="0">
-              <a:buNone/>
-            </a:pPr>
-            <a:r>
-              <a:rPr lang="en-US" sz="1500" dirty="0">
-                <a:solidFill>
-                  <a:srgbClr val="A9A9C4"/>
-                </a:solidFill>
-                <a:latin typeface="Arial" pitchFamily="34" charset="0"/>
-                <a:ea typeface="Arial" pitchFamily="34" charset="-122"/>
-                <a:cs typeface="Arial" pitchFamily="34" charset="-120"/>
-              </a:rPr>
-              <a:t>Asking the same AI "are you sure?" is not a check. LEAVE the answer, open a second, independent source. That's lateral reading.</a:t>
-            </a:r>
-            <a:endParaRPr lang="en-US" sz="1500" dirty="0"/>
+              <a:t>Leave the answer. Open a second, independent source: an encyclopedia, a textbook, a new search tab. Does it agree?</a:t>
+            </a:r>
+            <a:endParaRPr lang="en-US" sz="1700" dirty="0"/>
           </a:p>
         </p:txBody>
       </p:sp>
@@ -5465,41 +5533,14 @@
       </p:sp>
       <p:sp>
         <p:nvSpPr>
-          <p:cNvPr id="4" name="Shape 2"/>
-          <p:cNvSpPr/>
-          <p:nvPr/>
-        </p:nvSpPr>
-        <p:spPr>
-          <a:xfrm>
-            <a:off x="7680960" y="146304"/>
-            <a:ext cx="960120" cy="310896"/>
-          </a:xfrm>
-          <a:prstGeom prst="roundRect">
-            <a:avLst>
-              <a:gd name="adj" fmla="val 50000"/>
-            </a:avLst>
-          </a:prstGeom>
-          <a:solidFill>
-            <a:srgbClr val="14141F"/>
-          </a:solidFill>
-          <a:ln w="15875">
-            <a:solidFill>
-              <a:srgbClr val="FFB020"/>
-            </a:solidFill>
-            <a:prstDash val="solid"/>
-          </a:ln>
-        </p:spPr>
-      </p:sp>
-      <p:sp>
-        <p:nvSpPr>
-          <p:cNvPr id="5" name="Text 3"/>
-          <p:cNvSpPr txBox="1"/>
-          <p:nvPr/>
-        </p:nvSpPr>
-        <p:spPr>
-          <a:xfrm>
-            <a:off x="7680960" y="146304"/>
-            <a:ext cx="960120" cy="310896"/>
+          <p:cNvPr id="4" name="Text 2"/>
+          <p:cNvSpPr txBox="1"/>
+          <p:nvPr/>
+        </p:nvSpPr>
+        <p:spPr>
+          <a:xfrm>
+            <a:off x="502920" y="502920"/>
+            <a:ext cx="8138160" cy="548640"/>
           </a:xfrm>
           <a:prstGeom prst="rect">
             <a:avLst/>
@@ -5511,11 +5552,11 @@
           <a:bodyPr wrap="square" lIns="0" tIns="0" rIns="0" bIns="0" rtlCol="0" anchor="ctr"/>
           <a:lstStyle/>
           <a:p>
-            <a:pPr algn="ctr" indent="0" marL="0">
-              <a:buNone/>
-            </a:pPr>
-            <a:r>
-              <a:rPr lang="en-US" sz="1000" b="1" dirty="0">
+            <a:pPr indent="0" marL="0">
+              <a:buNone/>
+            </a:pPr>
+            <a:r>
+              <a:rPr lang="en-US" sz="2600" b="1" dirty="0">
                 <a:solidFill>
                   <a:srgbClr val="FFB020"/>
                 </a:solidFill>
@@ -5523,164 +5564,22 @@
                 <a:ea typeface="Arial" pitchFamily="34" charset="-122"/>
                 <a:cs typeface="Arial" pitchFamily="34" charset="-120"/>
               </a:rPr>
-              <a:t>21 MIN</a:t>
-            </a:r>
-            <a:endParaRPr lang="en-US" sz="1000" dirty="0"/>
-          </a:p>
-        </p:txBody>
-      </p:sp>
-      <p:sp>
-        <p:nvSpPr>
-          <p:cNvPr id="6" name="Text 4"/>
-          <p:cNvSpPr txBox="1"/>
-          <p:nvPr/>
-        </p:nvSpPr>
-        <p:spPr>
-          <a:xfrm>
-            <a:off x="502920" y="502920"/>
-            <a:ext cx="7040880" cy="548640"/>
-          </a:xfrm>
-          <a:prstGeom prst="rect">
-            <a:avLst/>
-          </a:prstGeom>
-          <a:noFill/>
-          <a:ln/>
-        </p:spPr>
-        <p:txBody>
-          <a:bodyPr wrap="square" lIns="0" tIns="0" rIns="0" bIns="0" rtlCol="0" anchor="ctr"/>
-          <a:lstStyle/>
-          <a:p>
-            <a:pPr indent="0" marL="0">
-              <a:buNone/>
-            </a:pPr>
-            <a:r>
-              <a:rPr lang="en-US" sz="2400" b="1" dirty="0">
-                <a:solidFill>
-                  <a:srgbClr val="FFB020"/>
-                </a:solidFill>
-                <a:latin typeface="Arial" pitchFamily="34" charset="0"/>
-                <a:ea typeface="Arial" pitchFamily="34" charset="-122"/>
-                <a:cs typeface="Arial" pitchFamily="34" charset="-120"/>
-              </a:rPr>
-              <a:t>Activity — The Fact Desk at The Comet</a:t>
-            </a:r>
-            <a:endParaRPr lang="en-US" sz="2400" dirty="0"/>
-          </a:p>
-        </p:txBody>
-      </p:sp>
-      <p:sp>
-        <p:nvSpPr>
-          <p:cNvPr id="8" name="Shape 5"/>
-          <p:cNvSpPr/>
-          <p:nvPr/>
-        </p:nvSpPr>
-        <p:spPr>
-          <a:xfrm>
-            <a:off x="502920" y="1234440"/>
-            <a:ext cx="457200" cy="457200"/>
-          </a:xfrm>
-          <a:prstGeom prst="ellipse">
-            <a:avLst/>
-          </a:prstGeom>
-          <a:solidFill>
-            <a:srgbClr val="FFB020"/>
-          </a:solidFill>
-          <a:ln w="12700">
-            <a:solidFill>
-              <a:srgbClr val="FFB020"/>
-            </a:solidFill>
-            <a:prstDash val="solid"/>
-          </a:ln>
-        </p:spPr>
-      </p:sp>
-      <p:sp>
-        <p:nvSpPr>
-          <p:cNvPr id="9" name="Text 6"/>
-          <p:cNvSpPr txBox="1"/>
-          <p:nvPr/>
-        </p:nvSpPr>
-        <p:spPr>
-          <a:xfrm>
-            <a:off x="502920" y="1234440"/>
-            <a:ext cx="457200" cy="457200"/>
-          </a:xfrm>
-          <a:prstGeom prst="rect">
-            <a:avLst/>
-          </a:prstGeom>
-          <a:noFill/>
-          <a:ln/>
-        </p:spPr>
-        <p:txBody>
-          <a:bodyPr wrap="square" lIns="0" tIns="0" rIns="0" bIns="0" rtlCol="0" anchor="ctr"/>
-          <a:lstStyle/>
-          <a:p>
-            <a:pPr algn="ctr" indent="0" marL="0">
-              <a:buNone/>
-            </a:pPr>
-            <a:r>
-              <a:rPr lang="en-US" sz="1600" b="1" dirty="0">
-                <a:solidFill>
-                  <a:srgbClr val="14141F"/>
-                </a:solidFill>
-                <a:latin typeface="Arial" pitchFamily="34" charset="0"/>
-                <a:ea typeface="Arial" pitchFamily="34" charset="-122"/>
-                <a:cs typeface="Arial" pitchFamily="34" charset="-120"/>
-              </a:rPr>
-              <a:t>1</a:t>
-            </a:r>
-            <a:endParaRPr lang="en-US" sz="1600" dirty="0"/>
-          </a:p>
-        </p:txBody>
-      </p:sp>
-      <p:sp>
-        <p:nvSpPr>
-          <p:cNvPr id="10" name="Text 7"/>
-          <p:cNvSpPr txBox="1"/>
-          <p:nvPr/>
-        </p:nvSpPr>
-        <p:spPr>
-          <a:xfrm>
-            <a:off x="1143000" y="1188720"/>
-            <a:ext cx="7498080" cy="320040"/>
-          </a:xfrm>
-          <a:prstGeom prst="rect">
-            <a:avLst/>
-          </a:prstGeom>
-          <a:noFill/>
-          <a:ln/>
-        </p:spPr>
-        <p:txBody>
-          <a:bodyPr wrap="square" lIns="0" tIns="0" rIns="0" bIns="0" rtlCol="0" anchor="ctr"/>
-          <a:lstStyle/>
-          <a:p>
-            <a:pPr indent="0" marL="0">
-              <a:buNone/>
-            </a:pPr>
-            <a:r>
-              <a:rPr lang="en-US" sz="1500" b="1" dirty="0">
-                <a:solidFill>
-                  <a:srgbClr val="FFB020"/>
-                </a:solidFill>
-                <a:latin typeface="Arial" pitchFamily="34" charset="0"/>
-                <a:ea typeface="Arial" pitchFamily="34" charset="-122"/>
-                <a:cs typeface="Arial" pitchFamily="34" charset="-120"/>
-              </a:rPr>
-              <a:t>Round 1   ·   7 min</a:t>
-            </a:r>
-            <a:endParaRPr lang="en-US" sz="1500" dirty="0"/>
-          </a:p>
-        </p:txBody>
-      </p:sp>
-      <p:sp>
-        <p:nvSpPr>
-          <p:cNvPr id="11" name="Text 8"/>
-          <p:cNvSpPr txBox="1"/>
-          <p:nvPr/>
-        </p:nvSpPr>
-        <p:spPr>
-          <a:xfrm>
-            <a:off x="1143000" y="1517904"/>
-            <a:ext cx="7498080" cy="612648"/>
+              <a:t>Stamp It — Desk Rules</a:t>
+            </a:r>
+            <a:endParaRPr lang="en-US" sz="2600" dirty="0"/>
+          </a:p>
+        </p:txBody>
+      </p:sp>
+      <p:sp>
+        <p:nvSpPr>
+          <p:cNvPr id="6" name="Text 3"/>
+          <p:cNvSpPr txBox="1"/>
+          <p:nvPr/>
+        </p:nvSpPr>
+        <p:spPr>
+          <a:xfrm>
+            <a:off x="594360" y="1188720"/>
+            <a:ext cx="7955280" cy="3406140"/>
           </a:xfrm>
           <a:prstGeom prst="rect">
             <a:avLst/>
@@ -5692,11 +5591,15 @@
           <a:bodyPr wrap="square" lIns="0" tIns="0" rIns="0" bIns="0" rtlCol="0" anchor="t"/>
           <a:lstStyle/>
           <a:p>
-            <a:pPr indent="0" marL="0">
-              <a:buNone/>
-            </a:pPr>
-            <a:r>
-              <a:rPr lang="en-US" sz="1300" dirty="0">
+            <a:pPr marL="342900" indent="-342900">
+              <a:spcAft>
+                <a:spcPts val="800"/>
+              </a:spcAft>
+              <a:buSzPct val="100000"/>
+              <a:buChar char="■"/>
+            </a:pPr>
+            <a:r>
+              <a:rPr lang="en-US" sz="1800" dirty="0">
                 <a:solidFill>
                   <a:srgbClr val="E8E8F5"/>
                 </a:solidFill>
@@ -5704,141 +5607,20 @@
                 <a:ea typeface="Arial" pitchFamily="34" charset="-122"/>
                 <a:cs typeface="Arial" pitchFamily="34" charset="-120"/>
               </a:rPr>
-              <a:t>Draft #1 (Priya's Moon column) together, each on your OWN sheet: underline, mark C or S, log your two riskiest claims, stamp it, write the note.</a:t>
-            </a:r>
-            <a:endParaRPr lang="en-US" sz="1300" dirty="0"/>
-          </a:p>
-        </p:txBody>
-      </p:sp>
-      <p:sp>
-        <p:nvSpPr>
-          <p:cNvPr id="12" name="Shape 9"/>
-          <p:cNvSpPr/>
-          <p:nvPr/>
-        </p:nvSpPr>
-        <p:spPr>
-          <a:xfrm>
-            <a:off x="502920" y="2286000"/>
-            <a:ext cx="457200" cy="457200"/>
-          </a:xfrm>
-          <a:prstGeom prst="ellipse">
-            <a:avLst/>
-          </a:prstGeom>
-          <a:solidFill>
-            <a:srgbClr val="FFB020"/>
-          </a:solidFill>
-          <a:ln w="12700">
-            <a:solidFill>
-              <a:srgbClr val="FFB020"/>
-            </a:solidFill>
-            <a:prstDash val="solid"/>
-          </a:ln>
-        </p:spPr>
-      </p:sp>
-      <p:sp>
-        <p:nvSpPr>
-          <p:cNvPr id="13" name="Text 10"/>
-          <p:cNvSpPr txBox="1"/>
-          <p:nvPr/>
-        </p:nvSpPr>
-        <p:spPr>
-          <a:xfrm>
-            <a:off x="502920" y="2286000"/>
-            <a:ext cx="457200" cy="457200"/>
-          </a:xfrm>
-          <a:prstGeom prst="rect">
-            <a:avLst/>
-          </a:prstGeom>
-          <a:noFill/>
-          <a:ln/>
-        </p:spPr>
-        <p:txBody>
-          <a:bodyPr wrap="square" lIns="0" tIns="0" rIns="0" bIns="0" rtlCol="0" anchor="ctr"/>
-          <a:lstStyle/>
-          <a:p>
-            <a:pPr algn="ctr" indent="0" marL="0">
-              <a:buNone/>
-            </a:pPr>
-            <a:r>
-              <a:rPr lang="en-US" sz="1600" b="1" dirty="0">
-                <a:solidFill>
-                  <a:srgbClr val="14141F"/>
-                </a:solidFill>
-                <a:latin typeface="Arial" pitchFamily="34" charset="0"/>
-                <a:ea typeface="Arial" pitchFamily="34" charset="-122"/>
-                <a:cs typeface="Arial" pitchFamily="34" charset="-120"/>
-              </a:rPr>
-              <a:t>2</a:t>
-            </a:r>
-            <a:endParaRPr lang="en-US" sz="1600" dirty="0"/>
-          </a:p>
-        </p:txBody>
-      </p:sp>
-      <p:sp>
-        <p:nvSpPr>
-          <p:cNvPr id="14" name="Text 11"/>
-          <p:cNvSpPr txBox="1"/>
-          <p:nvPr/>
-        </p:nvSpPr>
-        <p:spPr>
-          <a:xfrm>
-            <a:off x="1143000" y="2240280"/>
-            <a:ext cx="7498080" cy="320040"/>
-          </a:xfrm>
-          <a:prstGeom prst="rect">
-            <a:avLst/>
-          </a:prstGeom>
-          <a:noFill/>
-          <a:ln/>
-        </p:spPr>
-        <p:txBody>
-          <a:bodyPr wrap="square" lIns="0" tIns="0" rIns="0" bIns="0" rtlCol="0" anchor="ctr"/>
-          <a:lstStyle/>
-          <a:p>
-            <a:pPr indent="0" marL="0">
-              <a:buNone/>
-            </a:pPr>
-            <a:r>
-              <a:rPr lang="en-US" sz="1500" b="1" dirty="0">
-                <a:solidFill>
-                  <a:srgbClr val="FFB020"/>
-                </a:solidFill>
-                <a:latin typeface="Arial" pitchFamily="34" charset="0"/>
-                <a:ea typeface="Arial" pitchFamily="34" charset="-122"/>
-                <a:cs typeface="Arial" pitchFamily="34" charset="-120"/>
-              </a:rPr>
-              <a:t>Round 2   ·   10 min</a:t>
-            </a:r>
-            <a:endParaRPr lang="en-US" sz="1500" dirty="0"/>
-          </a:p>
-        </p:txBody>
-      </p:sp>
-      <p:sp>
-        <p:nvSpPr>
-          <p:cNvPr id="15" name="Text 12"/>
-          <p:cNvSpPr txBox="1"/>
-          <p:nvPr/>
-        </p:nvSpPr>
-        <p:spPr>
-          <a:xfrm>
-            <a:off x="1143000" y="2569464"/>
-            <a:ext cx="7498080" cy="612648"/>
-          </a:xfrm>
-          <a:prstGeom prst="rect">
-            <a:avLst/>
-          </a:prstGeom>
-          <a:noFill/>
-          <a:ln/>
-        </p:spPr>
-        <p:txBody>
-          <a:bodyPr wrap="square" lIns="0" tIns="0" rIns="0" bIns="0" rtlCol="0" anchor="t"/>
-          <a:lstStyle/>
-          <a:p>
-            <a:pPr indent="0" marL="0">
-              <a:buNone/>
-            </a:pPr>
-            <a:r>
-              <a:rPr lang="en-US" sz="1300" dirty="0">
+              <a:t>RUN — clean. Every C claim confirmed by a second, independent source.</a:t>
+            </a:r>
+            <a:endParaRPr lang="en-US" sz="1800" dirty="0"/>
+          </a:p>
+          <a:p>
+            <a:pPr marL="342900" indent="-342900">
+              <a:spcAft>
+                <a:spcPts val="800"/>
+              </a:spcAft>
+              <a:buSzPct val="100000"/>
+              <a:buChar char="■"/>
+            </a:pPr>
+            <a:r>
+              <a:rPr lang="en-US" sz="1800" dirty="0">
                 <a:solidFill>
                   <a:srgbClr val="E8E8F5"/>
                 </a:solidFill>
@@ -5846,141 +5628,20 @@
                 <a:ea typeface="Arial" pitchFamily="34" charset="-122"/>
                 <a:cs typeface="Arial" pitchFamily="34" charset="-120"/>
               </a:rPr>
-              <a:t>Partner A leads Draft #2, Partner B leads Draft #3 — each on your own sheet (6 min). Swap: add one claim they missed (2). Owners stamp and note (2).</a:t>
-            </a:r>
-            <a:endParaRPr lang="en-US" sz="1300" dirty="0"/>
-          </a:p>
-        </p:txBody>
-      </p:sp>
-      <p:sp>
-        <p:nvSpPr>
-          <p:cNvPr id="16" name="Shape 13"/>
-          <p:cNvSpPr/>
-          <p:nvPr/>
-        </p:nvSpPr>
-        <p:spPr>
-          <a:xfrm>
-            <a:off x="502920" y="3337560"/>
-            <a:ext cx="457200" cy="457200"/>
-          </a:xfrm>
-          <a:prstGeom prst="ellipse">
-            <a:avLst/>
-          </a:prstGeom>
-          <a:solidFill>
-            <a:srgbClr val="FFB020"/>
-          </a:solidFill>
-          <a:ln w="12700">
-            <a:solidFill>
-              <a:srgbClr val="FFB020"/>
-            </a:solidFill>
-            <a:prstDash val="solid"/>
-          </a:ln>
-        </p:spPr>
-      </p:sp>
-      <p:sp>
-        <p:nvSpPr>
-          <p:cNvPr id="17" name="Text 14"/>
-          <p:cNvSpPr txBox="1"/>
-          <p:nvPr/>
-        </p:nvSpPr>
-        <p:spPr>
-          <a:xfrm>
-            <a:off x="502920" y="3337560"/>
-            <a:ext cx="457200" cy="457200"/>
-          </a:xfrm>
-          <a:prstGeom prst="rect">
-            <a:avLst/>
-          </a:prstGeom>
-          <a:noFill/>
-          <a:ln/>
-        </p:spPr>
-        <p:txBody>
-          <a:bodyPr wrap="square" lIns="0" tIns="0" rIns="0" bIns="0" rtlCol="0" anchor="ctr"/>
-          <a:lstStyle/>
-          <a:p>
-            <a:pPr algn="ctr" indent="0" marL="0">
-              <a:buNone/>
-            </a:pPr>
-            <a:r>
-              <a:rPr lang="en-US" sz="1600" b="1" dirty="0">
-                <a:solidFill>
-                  <a:srgbClr val="14141F"/>
-                </a:solidFill>
-                <a:latin typeface="Arial" pitchFamily="34" charset="0"/>
-                <a:ea typeface="Arial" pitchFamily="34" charset="-122"/>
-                <a:cs typeface="Arial" pitchFamily="34" charset="-120"/>
-              </a:rPr>
-              <a:t>3</a:t>
-            </a:r>
-            <a:endParaRPr lang="en-US" sz="1600" dirty="0"/>
-          </a:p>
-        </p:txBody>
-      </p:sp>
-      <p:sp>
-        <p:nvSpPr>
-          <p:cNvPr id="18" name="Text 15"/>
-          <p:cNvSpPr txBox="1"/>
-          <p:nvPr/>
-        </p:nvSpPr>
-        <p:spPr>
-          <a:xfrm>
-            <a:off x="1143000" y="3291840"/>
-            <a:ext cx="7498080" cy="320040"/>
-          </a:xfrm>
-          <a:prstGeom prst="rect">
-            <a:avLst/>
-          </a:prstGeom>
-          <a:noFill/>
-          <a:ln/>
-        </p:spPr>
-        <p:txBody>
-          <a:bodyPr wrap="square" lIns="0" tIns="0" rIns="0" bIns="0" rtlCol="0" anchor="ctr"/>
-          <a:lstStyle/>
-          <a:p>
-            <a:pPr indent="0" marL="0">
-              <a:buNone/>
-            </a:pPr>
-            <a:r>
-              <a:rPr lang="en-US" sz="1500" b="1" dirty="0">
-                <a:solidFill>
-                  <a:srgbClr val="FFB020"/>
-                </a:solidFill>
-                <a:latin typeface="Arial" pitchFamily="34" charset="0"/>
-                <a:ea typeface="Arial" pitchFamily="34" charset="-122"/>
-                <a:cs typeface="Arial" pitchFamily="34" charset="-120"/>
-              </a:rPr>
-              <a:t>Verdicts out loud   ·   4 min</a:t>
-            </a:r>
-            <a:endParaRPr lang="en-US" sz="1500" dirty="0"/>
-          </a:p>
-        </p:txBody>
-      </p:sp>
-      <p:sp>
-        <p:nvSpPr>
-          <p:cNvPr id="19" name="Text 16"/>
-          <p:cNvSpPr txBox="1"/>
-          <p:nvPr/>
-        </p:nvSpPr>
-        <p:spPr>
-          <a:xfrm>
-            <a:off x="1143000" y="3621024"/>
-            <a:ext cx="7498080" cy="612648"/>
-          </a:xfrm>
-          <a:prstGeom prst="rect">
-            <a:avLst/>
-          </a:prstGeom>
-          <a:noFill/>
-          <a:ln/>
-        </p:spPr>
-        <p:txBody>
-          <a:bodyPr wrap="square" lIns="0" tIns="0" rIns="0" bIns="0" rtlCol="0" anchor="t"/>
-          <a:lstStyle/>
-          <a:p>
-            <a:pPr indent="0" marL="0">
-              <a:buNone/>
-            </a:pPr>
-            <a:r>
-              <a:rPr lang="en-US" sz="1300" dirty="0">
+              <a:t>FIX — correct it, then print. Does the writer's big conclusion still stand once the facts are fixed?</a:t>
+            </a:r>
+            <a:endParaRPr lang="en-US" sz="1800" dirty="0"/>
+          </a:p>
+          <a:p>
+            <a:pPr marL="342900" indent="-342900">
+              <a:spcAft>
+                <a:spcPts val="800"/>
+              </a:spcAft>
+              <a:buSzPct val="100000"/>
+              <a:buChar char="■"/>
+            </a:pPr>
+            <a:r>
+              <a:rPr lang="en-US" sz="1800" dirty="0">
                 <a:solidFill>
                   <a:srgbClr val="E8E8F5"/>
                 </a:solidFill>
@@ -5988,9 +5649,72 @@
                 <a:ea typeface="Arial" pitchFamily="34" charset="-122"/>
                 <a:cs typeface="Arial" pitchFamily="34" charset="-120"/>
               </a:rPr>
-              <a:t>Per draft, one desk per stamp gives its verdict and best evidence. Then hands up — your teacher tallies the room on the board.</a:t>
-            </a:r>
-            <a:endParaRPr lang="en-US" sz="1300" dirty="0"/>
+              <a:t>KILL — the core claim fails. Cut the story. Draw a big X across the draft.</a:t>
+            </a:r>
+            <a:endParaRPr lang="en-US" sz="1800" dirty="0"/>
+          </a:p>
+          <a:p>
+            <a:pPr marL="342900" indent="-342900">
+              <a:spcAft>
+                <a:spcPts val="800"/>
+              </a:spcAft>
+              <a:buSzPct val="100000"/>
+              <a:buChar char="■"/>
+            </a:pPr>
+            <a:r>
+              <a:rPr lang="en-US" sz="1800" dirty="0">
+                <a:solidFill>
+                  <a:srgbClr val="E8E8F5"/>
+                </a:solidFill>
+                <a:latin typeface="Arial" pitchFamily="34" charset="0"/>
+                <a:ea typeface="Arial" pitchFamily="34" charset="-122"/>
+                <a:cs typeface="Arial" pitchFamily="34" charset="-120"/>
+              </a:rPr>
+              <a:t>A quote is a claim. No traceable source, no print.</a:t>
+            </a:r>
+            <a:endParaRPr lang="en-US" sz="1800" dirty="0"/>
+          </a:p>
+          <a:p>
+            <a:pPr marL="342900" indent="-342900">
+              <a:spcAft>
+                <a:spcPts val="800"/>
+              </a:spcAft>
+              <a:buSzPct val="100000"/>
+              <a:buChar char="■"/>
+            </a:pPr>
+            <a:r>
+              <a:rPr lang="en-US" sz="1800" dirty="0">
+                <a:solidFill>
+                  <a:srgbClr val="E8E8F5"/>
+                </a:solidFill>
+                <a:latin typeface="Arial" pitchFamily="34" charset="0"/>
+                <a:ea typeface="Arial" pitchFamily="34" charset="-122"/>
+                <a:cs typeface="Arial" pitchFamily="34" charset="-120"/>
+              </a:rPr>
+              <a:t>Back every stamp with evidence: the claim, the fix, the second source.</a:t>
+            </a:r>
+            <a:endParaRPr lang="en-US" sz="1800" dirty="0"/>
+          </a:p>
+          <a:p>
+            <a:pPr marL="342900" indent="-342900">
+              <a:spcAft>
+                <a:spcPts val="800"/>
+              </a:spcAft>
+              <a:buSzPct val="100000"/>
+              <a:buChar char="■"/>
+            </a:pPr>
+            <a:r>
+              <a:rPr lang="en-US" sz="1800" dirty="0">
+                <a:solidFill>
+                  <a:srgbClr val="E8E8F5"/>
+                </a:solidFill>
+                <a:latin typeface="Arial" pitchFamily="34" charset="0"/>
+                <a:ea typeface="Arial" pitchFamily="34" charset="-122"/>
+                <a:cs typeface="Arial" pitchFamily="34" charset="-120"/>
+              </a:rPr>
+              <a:t>Partner A is the partner whose first name comes first in the alphabet.</a:t>
+            </a:r>
+            <a:endParaRPr lang="en-US" sz="1800" dirty="0"/>
           </a:p>
         </p:txBody>
       </p:sp>
@@ -6106,14 +5830,80 @@
       </p:sp>
       <p:sp>
         <p:nvSpPr>
-          <p:cNvPr id="4" name="Text 2"/>
+          <p:cNvPr id="4" name="Shape 2"/>
+          <p:cNvSpPr/>
+          <p:nvPr/>
+        </p:nvSpPr>
+        <p:spPr>
+          <a:xfrm>
+            <a:off x="7680960" y="146304"/>
+            <a:ext cx="960120" cy="310896"/>
+          </a:xfrm>
+          <a:prstGeom prst="roundRect">
+            <a:avLst>
+              <a:gd name="adj" fmla="val 50000"/>
+            </a:avLst>
+          </a:prstGeom>
+          <a:solidFill>
+            <a:srgbClr val="14141F"/>
+          </a:solidFill>
+          <a:ln w="15875">
+            <a:solidFill>
+              <a:srgbClr val="FFB020"/>
+            </a:solidFill>
+            <a:prstDash val="solid"/>
+          </a:ln>
+        </p:spPr>
+      </p:sp>
+      <p:sp>
+        <p:nvSpPr>
+          <p:cNvPr id="5" name="Text 3"/>
+          <p:cNvSpPr txBox="1"/>
+          <p:nvPr/>
+        </p:nvSpPr>
+        <p:spPr>
+          <a:xfrm>
+            <a:off x="7680960" y="146304"/>
+            <a:ext cx="960120" cy="310896"/>
+          </a:xfrm>
+          <a:prstGeom prst="rect">
+            <a:avLst/>
+          </a:prstGeom>
+          <a:noFill/>
+          <a:ln/>
+        </p:spPr>
+        <p:txBody>
+          <a:bodyPr wrap="square" lIns="0" tIns="0" rIns="0" bIns="0" rtlCol="0" anchor="ctr"/>
+          <a:lstStyle/>
+          <a:p>
+            <a:pPr algn="ctr" indent="0" marL="0">
+              <a:buNone/>
+            </a:pPr>
+            <a:r>
+              <a:rPr lang="en-US" sz="1000" b="1" dirty="0">
+                <a:solidFill>
+                  <a:srgbClr val="FFB020"/>
+                </a:solidFill>
+                <a:latin typeface="Arial" pitchFamily="34" charset="0"/>
+                <a:ea typeface="Arial" pitchFamily="34" charset="-122"/>
+                <a:cs typeface="Arial" pitchFamily="34" charset="-120"/>
+              </a:rPr>
+              <a:t>21 MIN</a:t>
+            </a:r>
+            <a:endParaRPr lang="en-US" sz="1000" dirty="0"/>
+          </a:p>
+        </p:txBody>
+      </p:sp>
+      <p:sp>
+        <p:nvSpPr>
+          <p:cNvPr id="6" name="Text 4"/>
           <p:cNvSpPr txBox="1"/>
           <p:nvPr/>
         </p:nvSpPr>
         <p:spPr>
           <a:xfrm>
             <a:off x="502920" y="502920"/>
-            <a:ext cx="8138160" cy="548640"/>
+            <a:ext cx="7040880" cy="548640"/>
           </a:xfrm>
           <a:prstGeom prst="rect">
             <a:avLst/>
@@ -6129,7 +5919,7 @@
               <a:buNone/>
             </a:pPr>
             <a:r>
-              <a:rPr lang="en-US" sz="2600" b="1" dirty="0">
+              <a:rPr lang="en-US" sz="2400" b="1" dirty="0">
                 <a:solidFill>
                   <a:srgbClr val="FFB020"/>
                 </a:solidFill>
@@ -6137,22 +5927,125 @@
                 <a:ea typeface="Arial" pitchFamily="34" charset="-122"/>
                 <a:cs typeface="Arial" pitchFamily="34" charset="-120"/>
               </a:rPr>
-              <a:t>Stamp It — Desk Rules</a:t>
-            </a:r>
-            <a:endParaRPr lang="en-US" sz="2600" dirty="0"/>
-          </a:p>
-        </p:txBody>
-      </p:sp>
-      <p:sp>
-        <p:nvSpPr>
-          <p:cNvPr id="6" name="Text 3"/>
-          <p:cNvSpPr txBox="1"/>
-          <p:nvPr/>
-        </p:nvSpPr>
-        <p:spPr>
-          <a:xfrm>
-            <a:off x="594360" y="1188720"/>
-            <a:ext cx="7955280" cy="3406140"/>
+              <a:t>Activity — The Fact Desk at The Comet</a:t>
+            </a:r>
+            <a:endParaRPr lang="en-US" sz="2400" dirty="0"/>
+          </a:p>
+        </p:txBody>
+      </p:sp>
+      <p:sp>
+        <p:nvSpPr>
+          <p:cNvPr id="8" name="Shape 5"/>
+          <p:cNvSpPr/>
+          <p:nvPr/>
+        </p:nvSpPr>
+        <p:spPr>
+          <a:xfrm>
+            <a:off x="502920" y="1234440"/>
+            <a:ext cx="457200" cy="457200"/>
+          </a:xfrm>
+          <a:prstGeom prst="ellipse">
+            <a:avLst/>
+          </a:prstGeom>
+          <a:solidFill>
+            <a:srgbClr val="FFB020"/>
+          </a:solidFill>
+          <a:ln w="12700">
+            <a:solidFill>
+              <a:srgbClr val="FFB020"/>
+            </a:solidFill>
+            <a:prstDash val="solid"/>
+          </a:ln>
+        </p:spPr>
+      </p:sp>
+      <p:sp>
+        <p:nvSpPr>
+          <p:cNvPr id="9" name="Text 6"/>
+          <p:cNvSpPr txBox="1"/>
+          <p:nvPr/>
+        </p:nvSpPr>
+        <p:spPr>
+          <a:xfrm>
+            <a:off x="502920" y="1234440"/>
+            <a:ext cx="457200" cy="457200"/>
+          </a:xfrm>
+          <a:prstGeom prst="rect">
+            <a:avLst/>
+          </a:prstGeom>
+          <a:noFill/>
+          <a:ln/>
+        </p:spPr>
+        <p:txBody>
+          <a:bodyPr wrap="square" lIns="0" tIns="0" rIns="0" bIns="0" rtlCol="0" anchor="ctr"/>
+          <a:lstStyle/>
+          <a:p>
+            <a:pPr algn="ctr" indent="0" marL="0">
+              <a:buNone/>
+            </a:pPr>
+            <a:r>
+              <a:rPr lang="en-US" sz="1600" b="1" dirty="0">
+                <a:solidFill>
+                  <a:srgbClr val="14141F"/>
+                </a:solidFill>
+                <a:latin typeface="Arial" pitchFamily="34" charset="0"/>
+                <a:ea typeface="Arial" pitchFamily="34" charset="-122"/>
+                <a:cs typeface="Arial" pitchFamily="34" charset="-120"/>
+              </a:rPr>
+              <a:t>1</a:t>
+            </a:r>
+            <a:endParaRPr lang="en-US" sz="1600" dirty="0"/>
+          </a:p>
+        </p:txBody>
+      </p:sp>
+      <p:sp>
+        <p:nvSpPr>
+          <p:cNvPr id="10" name="Text 7"/>
+          <p:cNvSpPr txBox="1"/>
+          <p:nvPr/>
+        </p:nvSpPr>
+        <p:spPr>
+          <a:xfrm>
+            <a:off x="1143000" y="1188720"/>
+            <a:ext cx="7498080" cy="320040"/>
+          </a:xfrm>
+          <a:prstGeom prst="rect">
+            <a:avLst/>
+          </a:prstGeom>
+          <a:noFill/>
+          <a:ln/>
+        </p:spPr>
+        <p:txBody>
+          <a:bodyPr wrap="square" lIns="0" tIns="0" rIns="0" bIns="0" rtlCol="0" anchor="ctr"/>
+          <a:lstStyle/>
+          <a:p>
+            <a:pPr indent="0" marL="0">
+              <a:buNone/>
+            </a:pPr>
+            <a:r>
+              <a:rPr lang="en-US" sz="1500" b="1" dirty="0">
+                <a:solidFill>
+                  <a:srgbClr val="FFB020"/>
+                </a:solidFill>
+                <a:latin typeface="Arial" pitchFamily="34" charset="0"/>
+                <a:ea typeface="Arial" pitchFamily="34" charset="-122"/>
+                <a:cs typeface="Arial" pitchFamily="34" charset="-120"/>
+              </a:rPr>
+              <a:t>Round 1   ·   7 min</a:t>
+            </a:r>
+            <a:endParaRPr lang="en-US" sz="1500" dirty="0"/>
+          </a:p>
+        </p:txBody>
+      </p:sp>
+      <p:sp>
+        <p:nvSpPr>
+          <p:cNvPr id="11" name="Text 8"/>
+          <p:cNvSpPr txBox="1"/>
+          <p:nvPr/>
+        </p:nvSpPr>
+        <p:spPr>
+          <a:xfrm>
+            <a:off x="1143000" y="1517904"/>
+            <a:ext cx="7498080" cy="612648"/>
           </a:xfrm>
           <a:prstGeom prst="rect">
             <a:avLst/>
@@ -6164,15 +6057,11 @@
           <a:bodyPr wrap="square" lIns="0" tIns="0" rIns="0" bIns="0" rtlCol="0" anchor="t"/>
           <a:lstStyle/>
           <a:p>
-            <a:pPr marL="342900" indent="-342900">
-              <a:spcAft>
-                <a:spcPts val="800"/>
-              </a:spcAft>
-              <a:buSzPct val="100000"/>
-              <a:buChar char="■"/>
-            </a:pPr>
-            <a:r>
-              <a:rPr lang="en-US" sz="1800" dirty="0">
+            <a:pPr indent="0" marL="0">
+              <a:buNone/>
+            </a:pPr>
+            <a:r>
+              <a:rPr lang="en-US" sz="1300" dirty="0">
                 <a:solidFill>
                   <a:srgbClr val="E8E8F5"/>
                 </a:solidFill>
@@ -6180,20 +6069,141 @@
                 <a:ea typeface="Arial" pitchFamily="34" charset="-122"/>
                 <a:cs typeface="Arial" pitchFamily="34" charset="-120"/>
               </a:rPr>
-              <a:t>RUN — clean. Every CHECK claim confirmed by a second, independent source.</a:t>
-            </a:r>
-            <a:endParaRPr lang="en-US" sz="1800" dirty="0"/>
-          </a:p>
-          <a:p>
-            <a:pPr marL="342900" indent="-342900">
-              <a:spcAft>
-                <a:spcPts val="800"/>
-              </a:spcAft>
-              <a:buSzPct val="100000"/>
-              <a:buChar char="■"/>
-            </a:pPr>
-            <a:r>
-              <a:rPr lang="en-US" sz="1800" dirty="0">
+              <a:t>Draft #1 (Priya's Moon column) together, each on your OWN sheet: underline, mark C or S, log your two riskiest claims, pick a stamp, write the note.</a:t>
+            </a:r>
+            <a:endParaRPr lang="en-US" sz="1300" dirty="0"/>
+          </a:p>
+        </p:txBody>
+      </p:sp>
+      <p:sp>
+        <p:nvSpPr>
+          <p:cNvPr id="12" name="Shape 9"/>
+          <p:cNvSpPr/>
+          <p:nvPr/>
+        </p:nvSpPr>
+        <p:spPr>
+          <a:xfrm>
+            <a:off x="502920" y="2286000"/>
+            <a:ext cx="457200" cy="457200"/>
+          </a:xfrm>
+          <a:prstGeom prst="ellipse">
+            <a:avLst/>
+          </a:prstGeom>
+          <a:solidFill>
+            <a:srgbClr val="FFB020"/>
+          </a:solidFill>
+          <a:ln w="12700">
+            <a:solidFill>
+              <a:srgbClr val="FFB020"/>
+            </a:solidFill>
+            <a:prstDash val="solid"/>
+          </a:ln>
+        </p:spPr>
+      </p:sp>
+      <p:sp>
+        <p:nvSpPr>
+          <p:cNvPr id="13" name="Text 10"/>
+          <p:cNvSpPr txBox="1"/>
+          <p:nvPr/>
+        </p:nvSpPr>
+        <p:spPr>
+          <a:xfrm>
+            <a:off x="502920" y="2286000"/>
+            <a:ext cx="457200" cy="457200"/>
+          </a:xfrm>
+          <a:prstGeom prst="rect">
+            <a:avLst/>
+          </a:prstGeom>
+          <a:noFill/>
+          <a:ln/>
+        </p:spPr>
+        <p:txBody>
+          <a:bodyPr wrap="square" lIns="0" tIns="0" rIns="0" bIns="0" rtlCol="0" anchor="ctr"/>
+          <a:lstStyle/>
+          <a:p>
+            <a:pPr algn="ctr" indent="0" marL="0">
+              <a:buNone/>
+            </a:pPr>
+            <a:r>
+              <a:rPr lang="en-US" sz="1600" b="1" dirty="0">
+                <a:solidFill>
+                  <a:srgbClr val="14141F"/>
+                </a:solidFill>
+                <a:latin typeface="Arial" pitchFamily="34" charset="0"/>
+                <a:ea typeface="Arial" pitchFamily="34" charset="-122"/>
+                <a:cs typeface="Arial" pitchFamily="34" charset="-120"/>
+              </a:rPr>
+              <a:t>2</a:t>
+            </a:r>
+            <a:endParaRPr lang="en-US" sz="1600" dirty="0"/>
+          </a:p>
+        </p:txBody>
+      </p:sp>
+      <p:sp>
+        <p:nvSpPr>
+          <p:cNvPr id="14" name="Text 11"/>
+          <p:cNvSpPr txBox="1"/>
+          <p:nvPr/>
+        </p:nvSpPr>
+        <p:spPr>
+          <a:xfrm>
+            <a:off x="1143000" y="2240280"/>
+            <a:ext cx="7498080" cy="320040"/>
+          </a:xfrm>
+          <a:prstGeom prst="rect">
+            <a:avLst/>
+          </a:prstGeom>
+          <a:noFill/>
+          <a:ln/>
+        </p:spPr>
+        <p:txBody>
+          <a:bodyPr wrap="square" lIns="0" tIns="0" rIns="0" bIns="0" rtlCol="0" anchor="ctr"/>
+          <a:lstStyle/>
+          <a:p>
+            <a:pPr indent="0" marL="0">
+              <a:buNone/>
+            </a:pPr>
+            <a:r>
+              <a:rPr lang="en-US" sz="1500" b="1" dirty="0">
+                <a:solidFill>
+                  <a:srgbClr val="FFB020"/>
+                </a:solidFill>
+                <a:latin typeface="Arial" pitchFamily="34" charset="0"/>
+                <a:ea typeface="Arial" pitchFamily="34" charset="-122"/>
+                <a:cs typeface="Arial" pitchFamily="34" charset="-120"/>
+              </a:rPr>
+              <a:t>Round 2   ·   10 min</a:t>
+            </a:r>
+            <a:endParaRPr lang="en-US" sz="1500" dirty="0"/>
+          </a:p>
+        </p:txBody>
+      </p:sp>
+      <p:sp>
+        <p:nvSpPr>
+          <p:cNvPr id="15" name="Text 12"/>
+          <p:cNvSpPr txBox="1"/>
+          <p:nvPr/>
+        </p:nvSpPr>
+        <p:spPr>
+          <a:xfrm>
+            <a:off x="1143000" y="2569464"/>
+            <a:ext cx="7498080" cy="612648"/>
+          </a:xfrm>
+          <a:prstGeom prst="rect">
+            <a:avLst/>
+          </a:prstGeom>
+          <a:noFill/>
+          <a:ln/>
+        </p:spPr>
+        <p:txBody>
+          <a:bodyPr wrap="square" lIns="0" tIns="0" rIns="0" bIns="0" rtlCol="0" anchor="t"/>
+          <a:lstStyle/>
+          <a:p>
+            <a:pPr indent="0" marL="0">
+              <a:buNone/>
+            </a:pPr>
+            <a:r>
+              <a:rPr lang="en-US" sz="1300" dirty="0">
                 <a:solidFill>
                   <a:srgbClr val="E8E8F5"/>
                 </a:solidFill>
@@ -6201,20 +6211,141 @@
                 <a:ea typeface="Arial" pitchFamily="34" charset="-122"/>
                 <a:cs typeface="Arial" pitchFamily="34" charset="-120"/>
               </a:rPr>
-              <a:t>FIX — correct it, then print. Does the writer's big conclusion still stand once the facts are fixed?</a:t>
-            </a:r>
-            <a:endParaRPr lang="en-US" sz="1800" dirty="0"/>
-          </a:p>
-          <a:p>
-            <a:pPr marL="342900" indent="-342900">
-              <a:spcAft>
-                <a:spcPts val="800"/>
-              </a:spcAft>
-              <a:buSzPct val="100000"/>
-              <a:buChar char="■"/>
-            </a:pPr>
-            <a:r>
-              <a:rPr lang="en-US" sz="1800" dirty="0">
+              <a:t>Partner A: Draft #2. Partner B: Draft #3. Stamp and note on your own sheet (6 min). Swap, add a claim they missed (2 min). Swap back and fix (2 min).</a:t>
+            </a:r>
+            <a:endParaRPr lang="en-US" sz="1300" dirty="0"/>
+          </a:p>
+        </p:txBody>
+      </p:sp>
+      <p:sp>
+        <p:nvSpPr>
+          <p:cNvPr id="16" name="Shape 13"/>
+          <p:cNvSpPr/>
+          <p:nvPr/>
+        </p:nvSpPr>
+        <p:spPr>
+          <a:xfrm>
+            <a:off x="502920" y="3337560"/>
+            <a:ext cx="457200" cy="457200"/>
+          </a:xfrm>
+          <a:prstGeom prst="ellipse">
+            <a:avLst/>
+          </a:prstGeom>
+          <a:solidFill>
+            <a:srgbClr val="FFB020"/>
+          </a:solidFill>
+          <a:ln w="12700">
+            <a:solidFill>
+              <a:srgbClr val="FFB020"/>
+            </a:solidFill>
+            <a:prstDash val="solid"/>
+          </a:ln>
+        </p:spPr>
+      </p:sp>
+      <p:sp>
+        <p:nvSpPr>
+          <p:cNvPr id="17" name="Text 14"/>
+          <p:cNvSpPr txBox="1"/>
+          <p:nvPr/>
+        </p:nvSpPr>
+        <p:spPr>
+          <a:xfrm>
+            <a:off x="502920" y="3337560"/>
+            <a:ext cx="457200" cy="457200"/>
+          </a:xfrm>
+          <a:prstGeom prst="rect">
+            <a:avLst/>
+          </a:prstGeom>
+          <a:noFill/>
+          <a:ln/>
+        </p:spPr>
+        <p:txBody>
+          <a:bodyPr wrap="square" lIns="0" tIns="0" rIns="0" bIns="0" rtlCol="0" anchor="ctr"/>
+          <a:lstStyle/>
+          <a:p>
+            <a:pPr algn="ctr" indent="0" marL="0">
+              <a:buNone/>
+            </a:pPr>
+            <a:r>
+              <a:rPr lang="en-US" sz="1600" b="1" dirty="0">
+                <a:solidFill>
+                  <a:srgbClr val="14141F"/>
+                </a:solidFill>
+                <a:latin typeface="Arial" pitchFamily="34" charset="0"/>
+                <a:ea typeface="Arial" pitchFamily="34" charset="-122"/>
+                <a:cs typeface="Arial" pitchFamily="34" charset="-120"/>
+              </a:rPr>
+              <a:t>3</a:t>
+            </a:r>
+            <a:endParaRPr lang="en-US" sz="1600" dirty="0"/>
+          </a:p>
+        </p:txBody>
+      </p:sp>
+      <p:sp>
+        <p:nvSpPr>
+          <p:cNvPr id="18" name="Text 15"/>
+          <p:cNvSpPr txBox="1"/>
+          <p:nvPr/>
+        </p:nvSpPr>
+        <p:spPr>
+          <a:xfrm>
+            <a:off x="1143000" y="3291840"/>
+            <a:ext cx="7498080" cy="320040"/>
+          </a:xfrm>
+          <a:prstGeom prst="rect">
+            <a:avLst/>
+          </a:prstGeom>
+          <a:noFill/>
+          <a:ln/>
+        </p:spPr>
+        <p:txBody>
+          <a:bodyPr wrap="square" lIns="0" tIns="0" rIns="0" bIns="0" rtlCol="0" anchor="ctr"/>
+          <a:lstStyle/>
+          <a:p>
+            <a:pPr indent="0" marL="0">
+              <a:buNone/>
+            </a:pPr>
+            <a:r>
+              <a:rPr lang="en-US" sz="1500" b="1" dirty="0">
+                <a:solidFill>
+                  <a:srgbClr val="FFB020"/>
+                </a:solidFill>
+                <a:latin typeface="Arial" pitchFamily="34" charset="0"/>
+                <a:ea typeface="Arial" pitchFamily="34" charset="-122"/>
+                <a:cs typeface="Arial" pitchFamily="34" charset="-120"/>
+              </a:rPr>
+              <a:t>Verdicts out loud   ·   4 min</a:t>
+            </a:r>
+            <a:endParaRPr lang="en-US" sz="1500" dirty="0"/>
+          </a:p>
+        </p:txBody>
+      </p:sp>
+      <p:sp>
+        <p:nvSpPr>
+          <p:cNvPr id="19" name="Text 16"/>
+          <p:cNvSpPr txBox="1"/>
+          <p:nvPr/>
+        </p:nvSpPr>
+        <p:spPr>
+          <a:xfrm>
+            <a:off x="1143000" y="3621024"/>
+            <a:ext cx="7498080" cy="612648"/>
+          </a:xfrm>
+          <a:prstGeom prst="rect">
+            <a:avLst/>
+          </a:prstGeom>
+          <a:noFill/>
+          <a:ln/>
+        </p:spPr>
+        <p:txBody>
+          <a:bodyPr wrap="square" lIns="0" tIns="0" rIns="0" bIns="0" rtlCol="0" anchor="t"/>
+          <a:lstStyle/>
+          <a:p>
+            <a:pPr indent="0" marL="0">
+              <a:buNone/>
+            </a:pPr>
+            <a:r>
+              <a:rPr lang="en-US" sz="1300" dirty="0">
                 <a:solidFill>
                   <a:srgbClr val="E8E8F5"/>
                 </a:solidFill>
@@ -6222,51 +6353,9 @@
                 <a:ea typeface="Arial" pitchFamily="34" charset="-122"/>
                 <a:cs typeface="Arial" pitchFamily="34" charset="-120"/>
               </a:rPr>
-              <a:t>KILL — the core claim fails. Cut the story.</a:t>
-            </a:r>
-            <a:endParaRPr lang="en-US" sz="1800" dirty="0"/>
-          </a:p>
-          <a:p>
-            <a:pPr marL="342900" indent="-342900">
-              <a:spcAft>
-                <a:spcPts val="800"/>
-              </a:spcAft>
-              <a:buSzPct val="100000"/>
-              <a:buChar char="■"/>
-            </a:pPr>
-            <a:r>
-              <a:rPr lang="en-US" sz="1800" dirty="0">
-                <a:solidFill>
-                  <a:srgbClr val="E8E8F5"/>
-                </a:solidFill>
-                <a:latin typeface="Arial" pitchFamily="34" charset="0"/>
-                <a:ea typeface="Arial" pitchFamily="34" charset="-122"/>
-                <a:cs typeface="Arial" pitchFamily="34" charset="-120"/>
-              </a:rPr>
-              <a:t>A quote is a claim. No traceable source, no print.</a:t>
-            </a:r>
-            <a:endParaRPr lang="en-US" sz="1800" dirty="0"/>
-          </a:p>
-          <a:p>
-            <a:pPr marL="342900" indent="-342900">
-              <a:spcAft>
-                <a:spcPts val="800"/>
-              </a:spcAft>
-              <a:buSzPct val="100000"/>
-              <a:buChar char="■"/>
-            </a:pPr>
-            <a:r>
-              <a:rPr lang="en-US" sz="1800" dirty="0">
-                <a:solidFill>
-                  <a:srgbClr val="E8E8F5"/>
-                </a:solidFill>
-                <a:latin typeface="Arial" pitchFamily="34" charset="0"/>
-                <a:ea typeface="Arial" pitchFamily="34" charset="-122"/>
-                <a:cs typeface="Arial" pitchFamily="34" charset="-120"/>
-              </a:rPr>
-              <a:t>Back every stamp with evidence: the claim, the fix, the second source.</a:t>
-            </a:r>
-            <a:endParaRPr lang="en-US" sz="1800" dirty="0"/>
+              <a:t>Draft by draft, hands up for RUN, FIX, or KILL while your teacher tallies. Then one desk per stamp gives its best evidence.</a:t>
+            </a:r>
+            <a:endParaRPr lang="en-US" sz="1300" dirty="0"/>
           </a:p>
         </p:txBody>
       </p:sp>

</xml_diff>

<commit_message>
Stranded words cleared in L1 and L3 by rewording, and the jobs claim reads one way across the unit: 'So far, AI mostly takes over tasks, not whole jobs.' The L5 cover keeps its thumbnail line, where 'first' carries the hedge
Co-Authored-By: Claude Opus 5.5 <noreply@anthropic.com>
Claude-Session: https://claude.ai/code/session_01VWaJFc84eoA3U4f2VjTKjw
</commit_message>
<xml_diff>
--- a/products/ai-fact-check-lab/dist/Hallucination Hunters - Slides.pptx
+++ b/products/ai-fact-check-lab/dist/Hallucination Hunters - Slides.pptx
@@ -4226,7 +4226,7 @@
               <a:buNone/>
             </a:pPr>
             <a:r>
-              <a:rPr lang="en-US" sz="1500" b="1" dirty="0">
+              <a:rPr lang="en-US" sz="1400" b="1" dirty="0">
                 <a:solidFill>
                   <a:srgbClr val="FFB020"/>
                 </a:solidFill>
@@ -4236,7 +4236,7 @@
               </a:rPr>
               <a:t>UNDERLINE</a:t>
             </a:r>
-            <a:endParaRPr lang="en-US" sz="1500" dirty="0"/>
+            <a:endParaRPr lang="en-US" sz="1400" dirty="0"/>
           </a:p>
         </p:txBody>
       </p:sp>
@@ -4395,7 +4395,7 @@
               <a:buNone/>
             </a:pPr>
             <a:r>
-              <a:rPr lang="en-US" sz="1700" b="1" dirty="0">
+              <a:rPr lang="en-US" sz="1400" b="1" dirty="0">
                 <a:solidFill>
                   <a:srgbClr val="FFB020"/>
                 </a:solidFill>
@@ -4405,7 +4405,7 @@
               </a:rPr>
               <a:t>RANK</a:t>
             </a:r>
-            <a:endParaRPr lang="en-US" sz="1700" dirty="0"/>
+            <a:endParaRPr lang="en-US" sz="1400" dirty="0"/>
           </a:p>
         </p:txBody>
       </p:sp>
@@ -4733,7 +4733,7 @@
               <a:buNone/>
             </a:pPr>
             <a:r>
-              <a:rPr lang="en-US" sz="1700" b="1" dirty="0">
+              <a:rPr lang="en-US" sz="1400" b="1" dirty="0">
                 <a:solidFill>
                   <a:srgbClr val="FFB020"/>
                 </a:solidFill>
@@ -4743,7 +4743,7 @@
               </a:rPr>
               <a:t>VERDICT</a:t>
             </a:r>
-            <a:endParaRPr lang="en-US" sz="1700" dirty="0"/>
+            <a:endParaRPr lang="en-US" sz="1400" dirty="0"/>
           </a:p>
         </p:txBody>
       </p:sp>

</xml_diff>

<commit_message>
L3's method step reads MARK, not RANK, on every surface and in the bundle's Day 3 board line: students write C or S above each claim, which is marking, and the News Desk pack built on this method already says so
Co-Authored-By: Claude Opus 5.5 <noreply@anthropic.com>
Claude-Session: https://claude.ai/code/session_01VWaJFc84eoA3U4f2VjTKjw
</commit_message>
<xml_diff>
--- a/products/ai-fact-check-lab/dist/Hallucination Hunters - Slides.pptx
+++ b/products/ai-fact-check-lab/dist/Hallucination Hunters - Slides.pptx
@@ -1137,7 +1137,7 @@
           <a:p>
             <a:r>
               <a:rPr lang="en-US" dirty="0"/>
-              <a:t>The method (7 min). Walk the four steps. On RANK: "You can't check everything. Would it hurt if wrong? That's a C. Low risk means not a record, not a number, and the ending doesn't need it. That's an S. 'Everybody knows it' is not a reason." Then advance: you model steps 1 and 2 on the next slide.</a:t>
+              <a:t>The method (7 min). Walk the four steps. On MARK: "You can't check everything. Would it hurt if wrong? That's a C. Low risk means not a record, not a number, and the ending doesn't need it. That's an S. 'Everybody knows it' is not a reason." Then advance: you model steps 1 and 2 on the next slide.</a:t>
             </a:r>
             <a:endParaRPr lang="en-US" dirty="0"/>
           </a:p>
@@ -1403,7 +1403,7 @@
           <a:p>
             <a:r>
               <a:rPr lang="en-US" dirty="0"/>
-              <a:t>Show this while sheets go out, then advance to the rounds. Two failure modes to watch for. The trusting desk clears everything ("it sounded right"): send them back to step 1. The paranoid desk kills everything ("it's all suspicious"): that's what RANK is for. Score the evidence, not the stamp.</a:t>
+              <a:t>Show this while sheets go out, then advance to the rounds. Two failure modes to watch for. The trusting desk clears everything ("it sounded right"): send them back to step 1. The paranoid desk kills everything ("it's all suspicious"): that's what MARK is for. Score the evidence, not the stamp.</a:t>
             </a:r>
             <a:endParaRPr lang="en-US" dirty="0"/>
           </a:p>
@@ -4403,7 +4403,7 @@
                 <a:ea typeface="Arial" pitchFamily="34" charset="-122"/>
                 <a:cs typeface="Arial" pitchFamily="34" charset="-120"/>
               </a:rPr>
-              <a:t>RANK</a:t>
+              <a:t>MARK</a:t>
             </a:r>
             <a:endParaRPr lang="en-US" sz="1400" dirty="0"/>
           </a:p>

</xml_diff>